<commit_message>
incorporate some enhancements to chapter 1
</commit_message>
<xml_diff>
--- a/20242-NLP-LLM/lecture notes/Part 1 - Introduction to NLP/1.1-introduction to NLP.pptx
+++ b/20242-NLP-LLM/lecture notes/Part 1 - Introduction to NLP/1.1-introduction to NLP.pptx
@@ -157,7 +157,7 @@
 <file path=ppt/revisionInfo.xml><?xml version="1.0" encoding="utf-8"?>
 <p1510:revInfo xmlns:a="http://schemas.openxmlformats.org/drawingml/2006/main" xmlns:r="http://schemas.openxmlformats.org/officeDocument/2006/relationships" xmlns:p1510="http://schemas.microsoft.com/office/powerpoint/2015/10/main">
   <p1510:revLst>
-    <p1510:client id="{CD467BAA-958C-43DD-AE6C-14EC1A9C72D6}" v="184" dt="2025-03-27T06:19:07.519"/>
+    <p1510:client id="{1430C6B2-0695-4939-9A81-7D403BE3894B}" v="4" dt="2025-04-03T03:24:44.757"/>
   </p1510:revLst>
 </p1510:revInfo>
 </file>
@@ -611,102 +611,6 @@
             <ac:spMk id="143" creationId="{00000000-0000-0000-0000-000000000000}"/>
           </ac:spMkLst>
         </pc:spChg>
-        <pc:spChg chg="del mod">
-          <ac:chgData name="Mohammed Fasha" userId="cc64f42d-a1a6-4f08-b97b-0c37f877119f" providerId="ADAL" clId="{CD467BAA-958C-43DD-AE6C-14EC1A9C72D6}" dt="2025-03-27T05:19:15.475" v="2597" actId="478"/>
-          <ac:spMkLst>
-            <pc:docMk/>
-            <pc:sldMk cId="0" sldId="274"/>
-            <ac:spMk id="144" creationId="{00000000-0000-0000-0000-000000000000}"/>
-          </ac:spMkLst>
-        </pc:spChg>
-        <pc:graphicFrameChg chg="add mod">
-          <ac:chgData name="Mohammed Fasha" userId="cc64f42d-a1a6-4f08-b97b-0c37f877119f" providerId="ADAL" clId="{CD467BAA-958C-43DD-AE6C-14EC1A9C72D6}" dt="2025-03-27T05:19:03.076" v="2596"/>
-          <ac:graphicFrameMkLst>
-            <pc:docMk/>
-            <pc:sldMk cId="0" sldId="274"/>
-            <ac:graphicFrameMk id="3" creationId="{943F8939-7019-FDC9-F76E-9D1D5E805B2D}"/>
-          </ac:graphicFrameMkLst>
-        </pc:graphicFrameChg>
-        <pc:graphicFrameChg chg="add mod">
-          <ac:chgData name="Mohammed Fasha" userId="cc64f42d-a1a6-4f08-b97b-0c37f877119f" providerId="ADAL" clId="{CD467BAA-958C-43DD-AE6C-14EC1A9C72D6}" dt="2025-03-27T05:19:03.076" v="2596"/>
-          <ac:graphicFrameMkLst>
-            <pc:docMk/>
-            <pc:sldMk cId="0" sldId="274"/>
-            <ac:graphicFrameMk id="4" creationId="{BE1417B1-B8A0-7DE0-ED24-CA72E0927F59}"/>
-          </ac:graphicFrameMkLst>
-        </pc:graphicFrameChg>
-        <pc:graphicFrameChg chg="add mod">
-          <ac:chgData name="Mohammed Fasha" userId="cc64f42d-a1a6-4f08-b97b-0c37f877119f" providerId="ADAL" clId="{CD467BAA-958C-43DD-AE6C-14EC1A9C72D6}" dt="2025-03-27T05:19:03.076" v="2596"/>
-          <ac:graphicFrameMkLst>
-            <pc:docMk/>
-            <pc:sldMk cId="0" sldId="274"/>
-            <ac:graphicFrameMk id="5" creationId="{F88CA1D9-6F8E-37E0-42F1-94A4243B1FDA}"/>
-          </ac:graphicFrameMkLst>
-        </pc:graphicFrameChg>
-        <pc:graphicFrameChg chg="add mod">
-          <ac:chgData name="Mohammed Fasha" userId="cc64f42d-a1a6-4f08-b97b-0c37f877119f" providerId="ADAL" clId="{CD467BAA-958C-43DD-AE6C-14EC1A9C72D6}" dt="2025-03-27T05:19:03.076" v="2596"/>
-          <ac:graphicFrameMkLst>
-            <pc:docMk/>
-            <pc:sldMk cId="0" sldId="274"/>
-            <ac:graphicFrameMk id="6" creationId="{8AF51F17-DADB-5748-4869-C80702E6706E}"/>
-          </ac:graphicFrameMkLst>
-        </pc:graphicFrameChg>
-        <pc:graphicFrameChg chg="add mod">
-          <ac:chgData name="Mohammed Fasha" userId="cc64f42d-a1a6-4f08-b97b-0c37f877119f" providerId="ADAL" clId="{CD467BAA-958C-43DD-AE6C-14EC1A9C72D6}" dt="2025-03-27T05:19:03.076" v="2596"/>
-          <ac:graphicFrameMkLst>
-            <pc:docMk/>
-            <pc:sldMk cId="0" sldId="274"/>
-            <ac:graphicFrameMk id="8" creationId="{09663822-EF0F-D18E-EA82-FDC8A1048DF2}"/>
-          </ac:graphicFrameMkLst>
-        </pc:graphicFrameChg>
-        <pc:graphicFrameChg chg="add mod">
-          <ac:chgData name="Mohammed Fasha" userId="cc64f42d-a1a6-4f08-b97b-0c37f877119f" providerId="ADAL" clId="{CD467BAA-958C-43DD-AE6C-14EC1A9C72D6}" dt="2025-03-27T05:19:03.076" v="2596"/>
-          <ac:graphicFrameMkLst>
-            <pc:docMk/>
-            <pc:sldMk cId="0" sldId="274"/>
-            <ac:graphicFrameMk id="9" creationId="{892984AE-2F94-77EA-F1E6-8C8E273D34E9}"/>
-          </ac:graphicFrameMkLst>
-        </pc:graphicFrameChg>
-        <pc:graphicFrameChg chg="add mod">
-          <ac:chgData name="Mohammed Fasha" userId="cc64f42d-a1a6-4f08-b97b-0c37f877119f" providerId="ADAL" clId="{CD467BAA-958C-43DD-AE6C-14EC1A9C72D6}" dt="2025-03-27T05:19:03.076" v="2596"/>
-          <ac:graphicFrameMkLst>
-            <pc:docMk/>
-            <pc:sldMk cId="0" sldId="274"/>
-            <ac:graphicFrameMk id="10" creationId="{9CC5E6A6-7767-6D93-0EA6-BA0A5BAB85D2}"/>
-          </ac:graphicFrameMkLst>
-        </pc:graphicFrameChg>
-        <pc:graphicFrameChg chg="add mod">
-          <ac:chgData name="Mohammed Fasha" userId="cc64f42d-a1a6-4f08-b97b-0c37f877119f" providerId="ADAL" clId="{CD467BAA-958C-43DD-AE6C-14EC1A9C72D6}" dt="2025-03-27T05:19:03.076" v="2596"/>
-          <ac:graphicFrameMkLst>
-            <pc:docMk/>
-            <pc:sldMk cId="0" sldId="274"/>
-            <ac:graphicFrameMk id="11" creationId="{448BB0A9-6D15-67E5-6B37-EA881BBEB9C3}"/>
-          </ac:graphicFrameMkLst>
-        </pc:graphicFrameChg>
-        <pc:graphicFrameChg chg="add mod">
-          <ac:chgData name="Mohammed Fasha" userId="cc64f42d-a1a6-4f08-b97b-0c37f877119f" providerId="ADAL" clId="{CD467BAA-958C-43DD-AE6C-14EC1A9C72D6}" dt="2025-03-27T05:19:03.076" v="2596"/>
-          <ac:graphicFrameMkLst>
-            <pc:docMk/>
-            <pc:sldMk cId="0" sldId="274"/>
-            <ac:graphicFrameMk id="12" creationId="{23A603C1-B7D4-B9AA-799E-577583F2E8FB}"/>
-          </ac:graphicFrameMkLst>
-        </pc:graphicFrameChg>
-        <pc:graphicFrameChg chg="add mod">
-          <ac:chgData name="Mohammed Fasha" userId="cc64f42d-a1a6-4f08-b97b-0c37f877119f" providerId="ADAL" clId="{CD467BAA-958C-43DD-AE6C-14EC1A9C72D6}" dt="2025-03-27T05:19:03.076" v="2596"/>
-          <ac:graphicFrameMkLst>
-            <pc:docMk/>
-            <pc:sldMk cId="0" sldId="274"/>
-            <ac:graphicFrameMk id="13" creationId="{B1839904-368A-BD0C-3DE6-8690B7B71E9C}"/>
-          </ac:graphicFrameMkLst>
-        </pc:graphicFrameChg>
-        <pc:graphicFrameChg chg="add del mod modGraphic">
-          <ac:chgData name="Mohammed Fasha" userId="cc64f42d-a1a6-4f08-b97b-0c37f877119f" providerId="ADAL" clId="{CD467BAA-958C-43DD-AE6C-14EC1A9C72D6}" dt="2025-03-27T05:21:53.225" v="2621" actId="478"/>
-          <ac:graphicFrameMkLst>
-            <pc:docMk/>
-            <pc:sldMk cId="0" sldId="274"/>
-            <ac:graphicFrameMk id="15" creationId="{EEA346B6-3EFC-18F8-90EA-B9CFD338305E}"/>
-          </ac:graphicFrameMkLst>
-        </pc:graphicFrameChg>
         <pc:graphicFrameChg chg="add mod modGraphic">
           <ac:chgData name="Mohammed Fasha" userId="cc64f42d-a1a6-4f08-b97b-0c37f877119f" providerId="ADAL" clId="{CD467BAA-958C-43DD-AE6C-14EC1A9C72D6}" dt="2025-03-27T05:21:58.114" v="2622" actId="1076"/>
           <ac:graphicFrameMkLst>
@@ -737,38 +641,6 @@
           <pc:docMk/>
           <pc:sldMk cId="0" sldId="276"/>
         </pc:sldMkLst>
-        <pc:spChg chg="add">
-          <ac:chgData name="Mohammed Fasha" userId="cc64f42d-a1a6-4f08-b97b-0c37f877119f" providerId="ADAL" clId="{CD467BAA-958C-43DD-AE6C-14EC1A9C72D6}" dt="2025-03-27T05:48:32.837" v="2652"/>
-          <ac:spMkLst>
-            <pc:docMk/>
-            <pc:sldMk cId="0" sldId="276"/>
-            <ac:spMk id="2" creationId="{565313BA-B162-8FC5-B3AE-29FBDBE33BAC}"/>
-          </ac:spMkLst>
-        </pc:spChg>
-        <pc:spChg chg="add">
-          <ac:chgData name="Mohammed Fasha" userId="cc64f42d-a1a6-4f08-b97b-0c37f877119f" providerId="ADAL" clId="{CD467BAA-958C-43DD-AE6C-14EC1A9C72D6}" dt="2025-03-27T05:48:42.218" v="2653"/>
-          <ac:spMkLst>
-            <pc:docMk/>
-            <pc:sldMk cId="0" sldId="276"/>
-            <ac:spMk id="3" creationId="{3823C19C-0038-FCAB-871B-D33B6755F5F0}"/>
-          </ac:spMkLst>
-        </pc:spChg>
-        <pc:spChg chg="add">
-          <ac:chgData name="Mohammed Fasha" userId="cc64f42d-a1a6-4f08-b97b-0c37f877119f" providerId="ADAL" clId="{CD467BAA-958C-43DD-AE6C-14EC1A9C72D6}" dt="2025-03-27T05:48:53.581" v="2657"/>
-          <ac:spMkLst>
-            <pc:docMk/>
-            <pc:sldMk cId="0" sldId="276"/>
-            <ac:spMk id="4" creationId="{7A1FEEAD-C5E8-D5E0-679A-BAD1BCEB242B}"/>
-          </ac:spMkLst>
-        </pc:spChg>
-        <pc:spChg chg="add">
-          <ac:chgData name="Mohammed Fasha" userId="cc64f42d-a1a6-4f08-b97b-0c37f877119f" providerId="ADAL" clId="{CD467BAA-958C-43DD-AE6C-14EC1A9C72D6}" dt="2025-03-27T05:49:04.348" v="2658"/>
-          <ac:spMkLst>
-            <pc:docMk/>
-            <pc:sldMk cId="0" sldId="276"/>
-            <ac:spMk id="5" creationId="{4650BECD-576E-2A7C-4AAD-51FCBD3740CC}"/>
-          </ac:spMkLst>
-        </pc:spChg>
         <pc:spChg chg="add mod">
           <ac:chgData name="Mohammed Fasha" userId="cc64f42d-a1a6-4f08-b97b-0c37f877119f" providerId="ADAL" clId="{CD467BAA-958C-43DD-AE6C-14EC1A9C72D6}" dt="2025-03-27T06:13:34.717" v="3490" actId="14100"/>
           <ac:spMkLst>
@@ -793,36 +665,12 @@
             <ac:spMk id="13" creationId="{329226C2-42F0-F928-D90B-44EDC623A50D}"/>
           </ac:spMkLst>
         </pc:spChg>
-        <pc:spChg chg="add">
-          <ac:chgData name="Mohammed Fasha" userId="cc64f42d-a1a6-4f08-b97b-0c37f877119f" providerId="ADAL" clId="{CD467BAA-958C-43DD-AE6C-14EC1A9C72D6}" dt="2025-03-27T06:04:17.819" v="3096"/>
-          <ac:spMkLst>
-            <pc:docMk/>
-            <pc:sldMk cId="0" sldId="276"/>
-            <ac:spMk id="14" creationId="{743A9E0B-6637-9B47-4EA7-1B324570A4F7}"/>
-          </ac:spMkLst>
-        </pc:spChg>
-        <pc:spChg chg="add del mod">
-          <ac:chgData name="Mohammed Fasha" userId="cc64f42d-a1a6-4f08-b97b-0c37f877119f" providerId="ADAL" clId="{CD467BAA-958C-43DD-AE6C-14EC1A9C72D6}" dt="2025-03-27T06:05:21.233" v="3127" actId="478"/>
-          <ac:spMkLst>
-            <pc:docMk/>
-            <pc:sldMk cId="0" sldId="276"/>
-            <ac:spMk id="15" creationId="{2B4F5602-A614-CBA7-5F65-AA87AA04C1D7}"/>
-          </ac:spMkLst>
-        </pc:spChg>
         <pc:spChg chg="add mod">
           <ac:chgData name="Mohammed Fasha" userId="cc64f42d-a1a6-4f08-b97b-0c37f877119f" providerId="ADAL" clId="{CD467BAA-958C-43DD-AE6C-14EC1A9C72D6}" dt="2025-03-27T06:14:34.525" v="3518" actId="20577"/>
           <ac:spMkLst>
             <pc:docMk/>
             <pc:sldMk cId="0" sldId="276"/>
             <ac:spMk id="16" creationId="{20602073-7B6E-A022-6568-96518DFCE75D}"/>
-          </ac:spMkLst>
-        </pc:spChg>
-        <pc:spChg chg="add mod">
-          <ac:chgData name="Mohammed Fasha" userId="cc64f42d-a1a6-4f08-b97b-0c37f877119f" providerId="ADAL" clId="{CD467BAA-958C-43DD-AE6C-14EC1A9C72D6}" dt="2025-03-27T06:04:53.040" v="3105"/>
-          <ac:spMkLst>
-            <pc:docMk/>
-            <pc:sldMk cId="0" sldId="276"/>
-            <ac:spMk id="17" creationId="{B540BE22-8186-46A0-F1C9-0A0C3133F8DA}"/>
           </ac:spMkLst>
         </pc:spChg>
         <pc:spChg chg="add mod">
@@ -849,14 +697,6 @@
             <ac:spMk id="148" creationId="{00000000-0000-0000-0000-000000000000}"/>
           </ac:spMkLst>
         </pc:spChg>
-        <pc:spChg chg="del mod">
-          <ac:chgData name="Mohammed Fasha" userId="cc64f42d-a1a6-4f08-b97b-0c37f877119f" providerId="ADAL" clId="{CD467BAA-958C-43DD-AE6C-14EC1A9C72D6}" dt="2025-03-27T05:59:10.765" v="2965" actId="478"/>
-          <ac:spMkLst>
-            <pc:docMk/>
-            <pc:sldMk cId="0" sldId="276"/>
-            <ac:spMk id="149" creationId="{00000000-0000-0000-0000-000000000000}"/>
-          </ac:spMkLst>
-        </pc:spChg>
         <pc:spChg chg="mod">
           <ac:chgData name="Mohammed Fasha" userId="cc64f42d-a1a6-4f08-b97b-0c37f877119f" providerId="ADAL" clId="{CD467BAA-958C-43DD-AE6C-14EC1A9C72D6}" dt="2025-03-27T06:13:38.309" v="3491" actId="14100"/>
           <ac:spMkLst>
@@ -873,14 +713,6 @@
             <ac:graphicFrameMk id="6" creationId="{421512CA-3C45-56E1-C100-CE4E8F0E14B1}"/>
           </ac:graphicFrameMkLst>
         </pc:graphicFrameChg>
-        <pc:graphicFrameChg chg="add del mod modGraphic">
-          <ac:chgData name="Mohammed Fasha" userId="cc64f42d-a1a6-4f08-b97b-0c37f877119f" providerId="ADAL" clId="{CD467BAA-958C-43DD-AE6C-14EC1A9C72D6}" dt="2025-03-27T06:00:07.919" v="3001" actId="21"/>
-          <ac:graphicFrameMkLst>
-            <pc:docMk/>
-            <pc:sldMk cId="0" sldId="276"/>
-            <ac:graphicFrameMk id="7" creationId="{5A50D271-6099-8848-32B9-52F0C96B2575}"/>
-          </ac:graphicFrameMkLst>
-        </pc:graphicFrameChg>
         <pc:graphicFrameChg chg="add mod modGraphic">
           <ac:chgData name="Mohammed Fasha" userId="cc64f42d-a1a6-4f08-b97b-0c37f877119f" providerId="ADAL" clId="{CD467BAA-958C-43DD-AE6C-14EC1A9C72D6}" dt="2025-03-27T06:11:08.603" v="3345" actId="1076"/>
           <ac:graphicFrameMkLst>
@@ -895,14 +727,6 @@
             <pc:docMk/>
             <pc:sldMk cId="0" sldId="276"/>
             <ac:graphicFrameMk id="12" creationId="{8BD96D17-9F2B-B7C4-8E4F-0B510D15EB97}"/>
-          </ac:graphicFrameMkLst>
-        </pc:graphicFrameChg>
-        <pc:graphicFrameChg chg="del">
-          <ac:chgData name="Mohammed Fasha" userId="cc64f42d-a1a6-4f08-b97b-0c37f877119f" providerId="ADAL" clId="{CD467BAA-958C-43DD-AE6C-14EC1A9C72D6}" dt="2025-03-27T05:51:12.737" v="2665" actId="478"/>
-          <ac:graphicFrameMkLst>
-            <pc:docMk/>
-            <pc:sldMk cId="0" sldId="276"/>
-            <ac:graphicFrameMk id="150" creationId="{00000000-0000-0000-0000-000000000000}"/>
           </ac:graphicFrameMkLst>
         </pc:graphicFrameChg>
       </pc:sldChg>
@@ -2031,6 +1855,38 @@
           <pc:docMk/>
           <pc:sldMk cId="3043812923" sldId="718"/>
         </pc:sldMkLst>
+      </pc:sldChg>
+    </pc:docChg>
+  </pc:docChgLst>
+  <pc:docChgLst>
+    <pc:chgData name="Mohammed Fasha" userId="cc64f42d-a1a6-4f08-b97b-0c37f877119f" providerId="ADAL" clId="{1430C6B2-0695-4939-9A81-7D403BE3894B}"/>
+    <pc:docChg chg="modSld">
+      <pc:chgData name="Mohammed Fasha" userId="cc64f42d-a1a6-4f08-b97b-0c37f877119f" providerId="ADAL" clId="{1430C6B2-0695-4939-9A81-7D403BE3894B}" dt="2025-04-03T03:24:44.757" v="3"/>
+      <pc:docMkLst>
+        <pc:docMk/>
+      </pc:docMkLst>
+      <pc:sldChg chg="addSp modSp">
+        <pc:chgData name="Mohammed Fasha" userId="cc64f42d-a1a6-4f08-b97b-0c37f877119f" providerId="ADAL" clId="{1430C6B2-0695-4939-9A81-7D403BE3894B}" dt="2025-04-03T03:24:44.757" v="3"/>
+        <pc:sldMkLst>
+          <pc:docMk/>
+          <pc:sldMk cId="0" sldId="281"/>
+        </pc:sldMkLst>
+        <pc:spChg chg="add mod">
+          <ac:chgData name="Mohammed Fasha" userId="cc64f42d-a1a6-4f08-b97b-0c37f877119f" providerId="ADAL" clId="{1430C6B2-0695-4939-9A81-7D403BE3894B}" dt="2025-04-03T03:24:44.757" v="3"/>
+          <ac:spMkLst>
+            <pc:docMk/>
+            <pc:sldMk cId="0" sldId="281"/>
+            <ac:spMk id="2" creationId="{F3E208A7-9D3D-C8FD-62BA-246574698579}"/>
+          </ac:spMkLst>
+        </pc:spChg>
+        <pc:picChg chg="mod">
+          <ac:chgData name="Mohammed Fasha" userId="cc64f42d-a1a6-4f08-b97b-0c37f877119f" providerId="ADAL" clId="{1430C6B2-0695-4939-9A81-7D403BE3894B}" dt="2025-04-03T03:22:32.423" v="2" actId="1076"/>
+          <ac:picMkLst>
+            <pc:docMk/>
+            <pc:sldMk cId="0" sldId="281"/>
+            <ac:picMk id="2050" creationId="{62F3EE30-1250-B624-2F54-4CC416515993}"/>
+          </ac:picMkLst>
+        </pc:picChg>
       </pc:sldChg>
     </pc:docChg>
   </pc:docChgLst>
@@ -5884,7 +5740,7 @@
           <a:p>
             <a:fld id="{13BA03A4-B9F1-404C-8A74-B1AFD6480953}" type="datetimeFigureOut">
               <a:rPr lang="en-US" smtClean="0"/>
-              <a:t>3/27/2025</a:t>
+              <a:t>4/3/2025</a:t>
             </a:fld>
             <a:endParaRPr lang="en-US"/>
           </a:p>
@@ -6298,7 +6154,7 @@
           <a:p>
             <a:fld id="{0DB78E95-DE77-44D3-BDB9-E242948FB112}" type="datetimeFigureOut">
               <a:rPr lang="en-US" smtClean="0"/>
-              <a:t>3/27/2025</a:t>
+              <a:t>4/3/2025</a:t>
             </a:fld>
             <a:endParaRPr lang="en-US"/>
           </a:p>
@@ -6526,7 +6382,7 @@
           <a:p>
             <a:fld id="{0DB78E95-DE77-44D3-BDB9-E242948FB112}" type="datetimeFigureOut">
               <a:rPr lang="en-US" smtClean="0"/>
-              <a:t>3/27/2025</a:t>
+              <a:t>4/3/2025</a:t>
             </a:fld>
             <a:endParaRPr lang="en-US"/>
           </a:p>
@@ -6734,7 +6590,7 @@
           <a:p>
             <a:fld id="{0DB78E95-DE77-44D3-BDB9-E242948FB112}" type="datetimeFigureOut">
               <a:rPr lang="en-US" smtClean="0"/>
-              <a:t>3/27/2025</a:t>
+              <a:t>4/3/2025</a:t>
             </a:fld>
             <a:endParaRPr lang="en-US"/>
           </a:p>
@@ -7461,7 +7317,7 @@
           <a:p>
             <a:fld id="{0DB78E95-DE77-44D3-BDB9-E242948FB112}" type="datetimeFigureOut">
               <a:rPr lang="en-US" smtClean="0"/>
-              <a:t>3/27/2025</a:t>
+              <a:t>4/3/2025</a:t>
             </a:fld>
             <a:endParaRPr lang="en-US"/>
           </a:p>
@@ -7840,7 +7696,7 @@
           <a:p>
             <a:fld id="{0DB78E95-DE77-44D3-BDB9-E242948FB112}" type="datetimeFigureOut">
               <a:rPr lang="en-US" smtClean="0"/>
-              <a:t>3/27/2025</a:t>
+              <a:t>4/3/2025</a:t>
             </a:fld>
             <a:endParaRPr lang="en-US"/>
           </a:p>
@@ -8252,7 +8108,7 @@
           <a:p>
             <a:fld id="{0DB78E95-DE77-44D3-BDB9-E242948FB112}" type="datetimeFigureOut">
               <a:rPr lang="en-US" smtClean="0"/>
-              <a:t>3/27/2025</a:t>
+              <a:t>4/3/2025</a:t>
             </a:fld>
             <a:endParaRPr lang="en-US"/>
           </a:p>
@@ -8393,7 +8249,7 @@
           <a:p>
             <a:fld id="{0DB78E95-DE77-44D3-BDB9-E242948FB112}" type="datetimeFigureOut">
               <a:rPr lang="en-US" smtClean="0"/>
-              <a:t>3/27/2025</a:t>
+              <a:t>4/3/2025</a:t>
             </a:fld>
             <a:endParaRPr lang="en-US"/>
           </a:p>
@@ -8506,7 +8362,7 @@
           <a:p>
             <a:fld id="{0DB78E95-DE77-44D3-BDB9-E242948FB112}" type="datetimeFigureOut">
               <a:rPr lang="en-US" smtClean="0"/>
-              <a:t>3/27/2025</a:t>
+              <a:t>4/3/2025</a:t>
             </a:fld>
             <a:endParaRPr lang="en-US"/>
           </a:p>
@@ -8817,7 +8673,7 @@
           <a:p>
             <a:fld id="{0DB78E95-DE77-44D3-BDB9-E242948FB112}" type="datetimeFigureOut">
               <a:rPr lang="en-US" smtClean="0"/>
-              <a:t>3/27/2025</a:t>
+              <a:t>4/3/2025</a:t>
             </a:fld>
             <a:endParaRPr lang="en-US"/>
           </a:p>
@@ -9105,7 +8961,7 @@
           <a:p>
             <a:fld id="{0DB78E95-DE77-44D3-BDB9-E242948FB112}" type="datetimeFigureOut">
               <a:rPr lang="en-US" smtClean="0"/>
-              <a:t>3/27/2025</a:t>
+              <a:t>4/3/2025</a:t>
             </a:fld>
             <a:endParaRPr lang="en-US"/>
           </a:p>
@@ -9346,7 +9202,7 @@
           <a:p>
             <a:fld id="{0DB78E95-DE77-44D3-BDB9-E242948FB112}" type="datetimeFigureOut">
               <a:rPr lang="en-US" smtClean="0"/>
-              <a:t>3/27/2025</a:t>
+              <a:t>4/3/2025</a:t>
             </a:fld>
             <a:endParaRPr lang="en-US"/>
           </a:p>
@@ -24525,8 +24381,8 @@
         </p:blipFill>
         <p:spPr>
           <a:xfrm>
-            <a:off x="7536277" y="2472480"/>
-            <a:ext cx="1114200" cy="190080"/>
+            <a:off x="8390293" y="4730618"/>
+            <a:ext cx="1469701" cy="289956"/>
           </a:xfrm>
           <a:prstGeom prst="rect">
             <a:avLst/>
@@ -24566,7 +24422,7 @@
         </p:blipFill>
         <p:spPr bwMode="auto">
           <a:xfrm>
-            <a:off x="3552268" y="3815532"/>
+            <a:off x="838080" y="3769934"/>
             <a:ext cx="4913870" cy="2764052"/>
           </a:xfrm>
           <a:prstGeom prst="rect">
@@ -24584,6 +24440,65 @@
           </a:extLst>
         </p:spPr>
       </p:pic>
+      <p:sp>
+        <p:nvSpPr>
+          <p:cNvPr id="2" name="PlaceHolder 2">
+            <a:extLst>
+              <a:ext uri="{FF2B5EF4-FFF2-40B4-BE49-F238E27FC236}">
+                <a16:creationId xmlns:a16="http://schemas.microsoft.com/office/drawing/2014/main" id="{F3E208A7-9D3D-C8FD-62BA-246574698579}"/>
+              </a:ext>
+            </a:extLst>
+          </p:cNvPr>
+          <p:cNvSpPr>
+            <a:spLocks noGrp="1"/>
+          </p:cNvSpPr>
+          <p:nvPr>
+            <p:ph/>
+          </p:nvPr>
+        </p:nvSpPr>
+        <p:spPr>
+          <a:xfrm>
+            <a:off x="7290915" y="5128518"/>
+            <a:ext cx="3940677" cy="356984"/>
+          </a:xfrm>
+          <a:prstGeom prst="rect">
+            <a:avLst/>
+          </a:prstGeom>
+          <a:noFill/>
+          <a:ln w="0">
+            <a:noFill/>
+          </a:ln>
+        </p:spPr>
+        <p:txBody>
+          <a:bodyPr lIns="91440" tIns="45720" rIns="91440" bIns="45720" anchor="t">
+            <a:noAutofit/>
+          </a:bodyPr>
+          <a:lstStyle/>
+          <a:p>
+            <a:pPr defTabSz="914400">
+              <a:lnSpc>
+                <a:spcPct val="90000"/>
+              </a:lnSpc>
+              <a:spcBef>
+                <a:spcPts val="1001"/>
+              </a:spcBef>
+              <a:buClr>
+                <a:srgbClr val="000000"/>
+              </a:buClr>
+            </a:pPr>
+            <a:r>
+              <a:rPr lang="en-US" sz="1400" b="0" u="none" strike="noStrike" dirty="0">
+                <a:solidFill>
+                  <a:schemeClr val="dk1"/>
+                </a:solidFill>
+                <a:uFillTx/>
+                <a:latin typeface="Calibri"/>
+              </a:rPr>
+              <a:t>Goto  Sentiment Analysis Example in the Notebook</a:t>
+            </a:r>
+          </a:p>
+        </p:txBody>
+      </p:sp>
     </p:spTree>
   </p:cSld>
   <p:clrMapOvr>
@@ -26643,39 +26558,32 @@
       </p:sp>
       <p:pic>
         <p:nvPicPr>
-          <p:cNvPr id="164" name="Graphic 6">
-            <a:hlinkClick r:id="rId2"/>
+          <p:cNvPr id="3" name="Picture 2">
             <a:extLst>
               <a:ext uri="{FF2B5EF4-FFF2-40B4-BE49-F238E27FC236}">
-                <a16:creationId xmlns:a16="http://schemas.microsoft.com/office/drawing/2014/main" id="{98D75408-003A-ED3D-468E-0FC6FA95A427}"/>
+                <a16:creationId xmlns:a16="http://schemas.microsoft.com/office/drawing/2014/main" id="{7E335CC5-CC5A-4EDC-EFCF-AD1985688A1C}"/>
               </a:ext>
             </a:extLst>
           </p:cNvPr>
-          <p:cNvPicPr/>
+          <p:cNvPicPr>
+            <a:picLocks noChangeAspect="1"/>
+          </p:cNvPicPr>
           <p:nvPr/>
         </p:nvPicPr>
         <p:blipFill>
-          <a:blip r:embed="rId3">
-            <a:extLst>
-              <a:ext uri="{96DAC541-7B7A-43D3-8B79-37D633B846F1}">
-                <asvg:svgBlip xmlns:asvg="http://schemas.microsoft.com/office/drawing/2016/SVG/main" r:embed="rId4"/>
-              </a:ext>
-            </a:extLst>
-          </a:blip>
-          <a:stretch/>
+          <a:blip r:embed="rId2"/>
+          <a:stretch>
+            <a:fillRect/>
+          </a:stretch>
         </p:blipFill>
         <p:spPr>
           <a:xfrm>
-            <a:off x="7505385" y="2206810"/>
-            <a:ext cx="1114200" cy="190080"/>
+            <a:off x="7536431" y="2173317"/>
+            <a:ext cx="1466850" cy="285750"/>
           </a:xfrm>
           <a:prstGeom prst="rect">
             <a:avLst/>
           </a:prstGeom>
-          <a:noFill/>
-          <a:ln w="0">
-            <a:noFill/>
-          </a:ln>
         </p:spPr>
       </p:pic>
     </p:spTree>
@@ -26777,8 +26685,8 @@
         </p:nvSpPr>
         <p:spPr>
           <a:xfrm>
-            <a:off x="838080" y="1706040"/>
-            <a:ext cx="10515240" cy="4990680"/>
+            <a:off x="838079" y="1706040"/>
+            <a:ext cx="11282033" cy="4990680"/>
           </a:xfrm>
           <a:prstGeom prst="rect">
             <a:avLst/>
@@ -26808,14 +26716,24 @@
               <a:buChar char="•"/>
             </a:pPr>
             <a:r>
-              <a:rPr lang="en-US" sz="2400" b="0" u="none" strike="noStrike">
+              <a:rPr lang="en-US" sz="2400" b="1" u="none" strike="noStrike" dirty="0">
                 <a:solidFill>
                   <a:schemeClr val="dk1"/>
                 </a:solidFill>
                 <a:uFillTx/>
                 <a:latin typeface="Calibri"/>
               </a:rPr>
-              <a:t>Limited context: Only consider a fixed number of previous words</a:t>
+              <a:t>Limited context: </a:t>
+            </a:r>
+            <a:r>
+              <a:rPr lang="en-US" sz="2400" b="0" u="none" strike="noStrike" dirty="0">
+                <a:solidFill>
+                  <a:schemeClr val="dk1"/>
+                </a:solidFill>
+                <a:uFillTx/>
+                <a:latin typeface="Calibri"/>
+              </a:rPr>
+              <a:t>Only consider a fixed number of previous words</a:t>
             </a:r>
           </a:p>
           <a:p>
@@ -26833,14 +26751,24 @@
               <a:buChar char="•"/>
             </a:pPr>
             <a:r>
-              <a:rPr lang="en-US" sz="2400" b="0" u="none" strike="noStrike">
+              <a:rPr lang="en-US" sz="2400" b="1" u="none" strike="noStrike" dirty="0">
                 <a:solidFill>
                   <a:schemeClr val="dk1"/>
                 </a:solidFill>
                 <a:uFillTx/>
                 <a:latin typeface="Calibri"/>
               </a:rPr>
-              <a:t>No long-range dependencies: Cannot capture relationships between distant words</a:t>
+              <a:t>No long-range dependencies: </a:t>
+            </a:r>
+            <a:r>
+              <a:rPr lang="en-US" sz="2400" b="0" u="none" strike="noStrike" dirty="0">
+                <a:solidFill>
+                  <a:schemeClr val="dk1"/>
+                </a:solidFill>
+                <a:uFillTx/>
+                <a:latin typeface="Calibri"/>
+              </a:rPr>
+              <a:t>Cannot capture relationships between distant words</a:t>
             </a:r>
           </a:p>
           <a:p>
@@ -26858,14 +26786,24 @@
               <a:buChar char="•"/>
             </a:pPr>
             <a:r>
-              <a:rPr lang="en-US" sz="2400" b="0" u="none" strike="noStrike">
+              <a:rPr lang="en-US" sz="2400" b="1" u="none" strike="noStrike" dirty="0">
                 <a:solidFill>
                   <a:schemeClr val="dk1"/>
                 </a:solidFill>
                 <a:uFillTx/>
                 <a:latin typeface="Calibri"/>
               </a:rPr>
-              <a:t>No semantic understanding: Model captures statistical patterns but not meaning</a:t>
+              <a:t>No semantic understanding: </a:t>
+            </a:r>
+            <a:r>
+              <a:rPr lang="en-US" sz="2400" b="0" u="none" strike="noStrike" dirty="0">
+                <a:solidFill>
+                  <a:schemeClr val="dk1"/>
+                </a:solidFill>
+                <a:uFillTx/>
+                <a:latin typeface="Calibri"/>
+              </a:rPr>
+              <a:t>Model captures statistical patterns but not meaning</a:t>
             </a:r>
           </a:p>
           <a:p>
@@ -26883,14 +26821,24 @@
               <a:buChar char="•"/>
             </a:pPr>
             <a:r>
-              <a:rPr lang="en-US" sz="2400" b="0" u="none" strike="noStrike">
+              <a:rPr lang="en-US" sz="2400" b="1" u="none" strike="noStrike" dirty="0">
                 <a:solidFill>
                   <a:schemeClr val="dk1"/>
                 </a:solidFill>
                 <a:uFillTx/>
                 <a:latin typeface="Calibri"/>
               </a:rPr>
-              <a:t>Memory intensive: Storing all possible n-grams requires significant space</a:t>
+              <a:t>Memory intensive: </a:t>
+            </a:r>
+            <a:r>
+              <a:rPr lang="en-US" sz="2400" b="0" u="none" strike="noStrike" dirty="0">
+                <a:solidFill>
+                  <a:schemeClr val="dk1"/>
+                </a:solidFill>
+                <a:uFillTx/>
+                <a:latin typeface="Calibri"/>
+              </a:rPr>
+              <a:t>Storing all possible n-grams requires significant space</a:t>
             </a:r>
           </a:p>
           <a:p>
@@ -26908,14 +26856,24 @@
               <a:buChar char="•"/>
             </a:pPr>
             <a:r>
-              <a:rPr lang="en-US" sz="2400" b="0" u="none" strike="noStrike">
+              <a:rPr lang="en-US" sz="2400" b="1" u="none" strike="noStrike" dirty="0">
                 <a:solidFill>
                   <a:schemeClr val="dk1"/>
                 </a:solidFill>
                 <a:uFillTx/>
                 <a:latin typeface="Calibri"/>
               </a:rPr>
-              <a:t>Data sparsity: Many valid word combinations don't appear in training data</a:t>
+              <a:t>Data sparsity: </a:t>
+            </a:r>
+            <a:r>
+              <a:rPr lang="en-US" sz="2400" b="0" u="none" strike="noStrike" dirty="0">
+                <a:solidFill>
+                  <a:schemeClr val="dk1"/>
+                </a:solidFill>
+                <a:uFillTx/>
+                <a:latin typeface="Calibri"/>
+              </a:rPr>
+              <a:t>Many valid word combinations don't appear in training data</a:t>
             </a:r>
           </a:p>
           <a:p>
@@ -26928,7 +26886,7 @@
               </a:spcBef>
               <a:buNone/>
             </a:pPr>
-            <a:endParaRPr lang="en-US" sz="2400" b="0" u="none" strike="noStrike">
+            <a:endParaRPr lang="en-US" sz="2400" b="0" u="none" strike="noStrike" dirty="0">
               <a:solidFill>
                 <a:schemeClr val="dk1"/>
               </a:solidFill>
@@ -27062,7 +27020,7 @@
               </a:tabLst>
             </a:pPr>
             <a:r>
-              <a:rPr lang="en-US" sz="2400" b="0" u="none" strike="noStrike">
+              <a:rPr lang="en-US" sz="2400" b="0" u="none" strike="noStrike" dirty="0">
                 <a:solidFill>
                   <a:schemeClr val="dk1"/>
                 </a:solidFill>
@@ -27086,7 +27044,7 @@
               </a:tabLst>
             </a:pPr>
             <a:r>
-              <a:rPr lang="en-US" sz="2400" b="1" u="none" strike="noStrike">
+              <a:rPr lang="en-US" sz="2400" b="1" u="none" strike="noStrike" dirty="0">
                 <a:solidFill>
                   <a:schemeClr val="dk1"/>
                 </a:solidFill>
@@ -27095,7 +27053,7 @@
               </a:rPr>
               <a:t>What It Means</a:t>
             </a:r>
-            <a:endParaRPr lang="en-US" sz="2400" b="0" u="none" strike="noStrike">
+            <a:endParaRPr lang="en-US" sz="2400" b="0" u="none" strike="noStrike" dirty="0">
               <a:solidFill>
                 <a:schemeClr val="dk1"/>
               </a:solidFill>
@@ -27121,7 +27079,7 @@
               </a:tabLst>
             </a:pPr>
             <a:r>
-              <a:rPr lang="en-US" sz="2400" b="1" u="none" strike="noStrike">
+              <a:rPr lang="en-US" sz="2400" b="1" u="none" strike="noStrike" dirty="0">
                 <a:solidFill>
                   <a:schemeClr val="dk1"/>
                 </a:solidFill>
@@ -27131,7 +27089,7 @@
               <a:t>Lower perplexity</a:t>
             </a:r>
             <a:r>
-              <a:rPr lang="en-US" sz="2400" b="0" u="none" strike="noStrike">
+              <a:rPr lang="en-US" sz="2400" b="0" u="none" strike="noStrike" dirty="0">
                 <a:solidFill>
                   <a:schemeClr val="dk1"/>
                 </a:solidFill>
@@ -27159,7 +27117,7 @@
               </a:tabLst>
             </a:pPr>
             <a:r>
-              <a:rPr lang="en-US" sz="2400" b="1" u="none" strike="noStrike">
+              <a:rPr lang="en-US" sz="2400" b="1" u="none" strike="noStrike" dirty="0">
                 <a:solidFill>
                   <a:schemeClr val="dk1"/>
                 </a:solidFill>
@@ -27169,7 +27127,7 @@
               <a:t>Higher perplexity</a:t>
             </a:r>
             <a:r>
-              <a:rPr lang="en-US" sz="2400" b="0" u="none" strike="noStrike">
+              <a:rPr lang="en-US" sz="2400" b="0" u="none" strike="noStrike" dirty="0">
                 <a:solidFill>
                   <a:schemeClr val="dk1"/>
                 </a:solidFill>
@@ -27193,7 +27151,7 @@
               </a:tabLst>
             </a:pPr>
             <a:r>
-              <a:rPr lang="en-US" sz="2400" b="1" u="none" strike="noStrike">
+              <a:rPr lang="en-US" sz="2400" b="1" u="none" strike="noStrike" dirty="0">
                 <a:solidFill>
                   <a:schemeClr val="dk1"/>
                 </a:solidFill>
@@ -27202,7 +27160,7 @@
               </a:rPr>
               <a:t>Simple Example</a:t>
             </a:r>
-            <a:endParaRPr lang="en-US" sz="2400" b="0" u="none" strike="noStrike">
+            <a:endParaRPr lang="en-US" sz="2400" b="0" u="none" strike="noStrike" dirty="0">
               <a:solidFill>
                 <a:schemeClr val="dk1"/>
               </a:solidFill>
@@ -27224,7 +27182,7 @@
               </a:tabLst>
             </a:pPr>
             <a:r>
-              <a:rPr lang="en-US" sz="2400" b="0" u="none" strike="noStrike">
+              <a:rPr lang="en-US" sz="2400" b="0" u="none" strike="noStrike" dirty="0">
                 <a:solidFill>
                   <a:schemeClr val="dk1"/>
                 </a:solidFill>
@@ -27252,7 +27210,7 @@
               </a:tabLst>
             </a:pPr>
             <a:r>
-              <a:rPr lang="en-US" sz="2400" b="0" u="none" strike="noStrike">
+              <a:rPr lang="en-US" sz="2400" b="0" u="none" strike="noStrike" dirty="0">
                 <a:solidFill>
                   <a:schemeClr val="dk1"/>
                 </a:solidFill>
@@ -27280,7 +27238,7 @@
               </a:tabLst>
             </a:pPr>
             <a:r>
-              <a:rPr lang="en-US" sz="2400" b="0" u="none" strike="noStrike">
+              <a:rPr lang="en-US" sz="2400" b="0" u="none" strike="noStrike" dirty="0">
                 <a:solidFill>
                   <a:schemeClr val="dk1"/>
                 </a:solidFill>
@@ -27291,7 +27249,7 @@
             </a:r>
           </a:p>
           <a:p>
-            <a:pPr marL="228600" indent="-228600" defTabSz="914400">
+            <a:pPr defTabSz="914400">
               <a:lnSpc>
                 <a:spcPct val="90000"/>
               </a:lnSpc>
@@ -27304,7 +27262,7 @@
               </a:tabLst>
             </a:pPr>
             <a:r>
-              <a:rPr lang="en-US" sz="2400" b="0" u="none" strike="noStrike">
+              <a:rPr lang="en-US" sz="2400" b="0" u="none" strike="noStrike" dirty="0">
                 <a:solidFill>
                   <a:schemeClr val="dk1"/>
                 </a:solidFill>
@@ -27328,7 +27286,7 @@
               </a:tabLst>
             </a:pPr>
             <a:r>
-              <a:rPr lang="en-US" sz="2400" b="1" u="none" strike="noStrike">
+              <a:rPr lang="en-US" sz="2400" b="1" u="none" strike="noStrike" dirty="0">
                 <a:solidFill>
                   <a:schemeClr val="dk1"/>
                 </a:solidFill>
@@ -27337,7 +27295,7 @@
               </a:rPr>
               <a:t>Real-World Comparison</a:t>
             </a:r>
-            <a:endParaRPr lang="en-US" sz="2400" b="0" u="none" strike="noStrike">
+            <a:endParaRPr lang="en-US" sz="2400" b="0" u="none" strike="noStrike" dirty="0">
               <a:solidFill>
                 <a:schemeClr val="dk1"/>
               </a:solidFill>
@@ -27359,7 +27317,7 @@
               </a:tabLst>
             </a:pPr>
             <a:r>
-              <a:rPr lang="en-US" sz="2400" b="0" u="none" strike="noStrike">
+              <a:rPr lang="en-US" sz="2400" b="0" u="none" strike="noStrike" dirty="0">
                 <a:solidFill>
                   <a:schemeClr val="dk1"/>
                 </a:solidFill>
@@ -27383,7 +27341,7 @@
               </a:tabLst>
             </a:pPr>
             <a:r>
-              <a:rPr lang="en-US" sz="2400" b="1" u="none" strike="noStrike">
+              <a:rPr lang="en-US" sz="2400" b="1" u="none" strike="noStrike" dirty="0">
                 <a:solidFill>
                   <a:schemeClr val="dk1"/>
                 </a:solidFill>
@@ -27392,7 +27350,7 @@
               </a:rPr>
               <a:t>Why It Matters</a:t>
             </a:r>
-            <a:endParaRPr lang="en-US" sz="2400" b="0" u="none" strike="noStrike">
+            <a:endParaRPr lang="en-US" sz="2400" b="0" u="none" strike="noStrike" dirty="0">
               <a:solidFill>
                 <a:schemeClr val="dk1"/>
               </a:solidFill>
@@ -27414,7 +27372,7 @@
               </a:tabLst>
             </a:pPr>
             <a:r>
-              <a:rPr lang="en-US" sz="2400" b="0" u="none" strike="noStrike">
+              <a:rPr lang="en-US" sz="2400" b="0" u="none" strike="noStrike" dirty="0">
                 <a:solidFill>
                   <a:schemeClr val="dk1"/>
                 </a:solidFill>
@@ -27442,7 +27400,7 @@
               </a:tabLst>
             </a:pPr>
             <a:r>
-              <a:rPr lang="en-US" sz="2400" b="0" u="none" strike="noStrike">
+              <a:rPr lang="en-US" sz="2400" b="0" u="none" strike="noStrike" dirty="0">
                 <a:solidFill>
                   <a:schemeClr val="dk1"/>
                 </a:solidFill>
@@ -27470,7 +27428,7 @@
               </a:tabLst>
             </a:pPr>
             <a:r>
-              <a:rPr lang="en-US" sz="2400" b="0" u="none" strike="noStrike">
+              <a:rPr lang="en-US" sz="2400" b="0" u="none" strike="noStrike" dirty="0">
                 <a:solidFill>
                   <a:schemeClr val="dk1"/>
                 </a:solidFill>
@@ -27498,7 +27456,7 @@
               </a:tabLst>
             </a:pPr>
             <a:r>
-              <a:rPr lang="en-US" sz="2400" b="0" u="none" strike="noStrike">
+              <a:rPr lang="en-US" sz="2400" b="0" u="none" strike="noStrike" dirty="0">
                 <a:solidFill>
                   <a:schemeClr val="dk1"/>
                 </a:solidFill>
@@ -27526,7 +27484,7 @@
               </a:tabLst>
             </a:pPr>
             <a:r>
-              <a:rPr lang="en-US" sz="2400" b="0" u="none" strike="noStrike">
+              <a:rPr lang="en-US" sz="2400" b="0" u="none" strike="noStrike" dirty="0">
                 <a:solidFill>
                   <a:schemeClr val="dk1"/>
                 </a:solidFill>
@@ -27549,7 +27507,7 @@
                 <a:tab pos="0" algn="l"/>
               </a:tabLst>
             </a:pPr>
-            <a:endParaRPr lang="en-US" sz="2400" b="0" u="none" strike="noStrike">
+            <a:endParaRPr lang="en-US" sz="2400" b="0" u="none" strike="noStrike" dirty="0">
               <a:solidFill>
                 <a:schemeClr val="dk1"/>
               </a:solidFill>

</xml_diff>

<commit_message>
modifications to part 1, may be a new run
</commit_message>
<xml_diff>
--- a/20242-NLP-LLM/lecture notes/Part 1 - Introduction to NLP/1.1-introduction to NLP.pptx
+++ b/20242-NLP-LLM/lecture notes/Part 1 - Introduction to NLP/1.1-introduction to NLP.pptx
@@ -168,12 +168,281 @@
 <p1510:revInfo xmlns:a="http://schemas.openxmlformats.org/drawingml/2006/main" xmlns:r="http://schemas.openxmlformats.org/officeDocument/2006/relationships" xmlns:p1510="http://schemas.microsoft.com/office/powerpoint/2015/10/main">
   <p1510:revLst>
     <p1510:client id="{1430C6B2-0695-4939-9A81-7D403BE3894B}" v="45" dt="2025-04-06T04:26:48.307"/>
+    <p1510:client id="{9DEFE369-4FE8-C0FA-AE89-88E89C96B65F}" v="51" dt="2025-04-07T19:02:15.269"/>
   </p1510:revLst>
 </p1510:revInfo>
 </file>
 
 <file path=ppt/changesInfos/changesInfo1.xml><?xml version="1.0" encoding="utf-8"?>
 <pc:chgInfo xmlns:a="http://schemas.openxmlformats.org/drawingml/2006/main" xmlns:r="http://schemas.openxmlformats.org/officeDocument/2006/relationships" xmlns:ac="http://schemas.microsoft.com/office/drawing/2013/main/command" xmlns:pc="http://schemas.microsoft.com/office/powerpoint/2013/main/command">
+  <pc:docChgLst>
+    <pc:chgData name="Mohammed Fasha" userId="cc64f42d-a1a6-4f08-b97b-0c37f877119f" providerId="ADAL" clId="{BECD4A7F-C1AF-4585-8C31-FE7D4FE3ED16}"/>
+    <pc:docChg chg="undo redo custSel addSld delSld modSld sldOrd">
+      <pc:chgData name="Mohammed Fasha" userId="cc64f42d-a1a6-4f08-b97b-0c37f877119f" providerId="ADAL" clId="{BECD4A7F-C1AF-4585-8C31-FE7D4FE3ED16}" dt="2025-01-05T16:36:16.605" v="1945" actId="1076"/>
+      <pc:docMkLst>
+        <pc:docMk/>
+      </pc:docMkLst>
+      <pc:sldChg chg="modSp mod">
+        <pc:chgData name="Mohammed Fasha" userId="cc64f42d-a1a6-4f08-b97b-0c37f877119f" providerId="ADAL" clId="{BECD4A7F-C1AF-4585-8C31-FE7D4FE3ED16}" dt="2024-12-30T18:47:27.683" v="988" actId="20577"/>
+        <pc:sldMkLst>
+          <pc:docMk/>
+          <pc:sldMk cId="2281221656" sldId="527"/>
+        </pc:sldMkLst>
+      </pc:sldChg>
+      <pc:sldChg chg="modSp mod">
+        <pc:chgData name="Mohammed Fasha" userId="cc64f42d-a1a6-4f08-b97b-0c37f877119f" providerId="ADAL" clId="{BECD4A7F-C1AF-4585-8C31-FE7D4FE3ED16}" dt="2024-12-27T13:59:26.893" v="366" actId="20577"/>
+        <pc:sldMkLst>
+          <pc:docMk/>
+          <pc:sldMk cId="3474268344" sldId="596"/>
+        </pc:sldMkLst>
+      </pc:sldChg>
+      <pc:sldChg chg="modSp mod">
+        <pc:chgData name="Mohammed Fasha" userId="cc64f42d-a1a6-4f08-b97b-0c37f877119f" providerId="ADAL" clId="{BECD4A7F-C1AF-4585-8C31-FE7D4FE3ED16}" dt="2024-12-30T18:44:34.649" v="884" actId="20577"/>
+        <pc:sldMkLst>
+          <pc:docMk/>
+          <pc:sldMk cId="916802035" sldId="651"/>
+        </pc:sldMkLst>
+      </pc:sldChg>
+      <pc:sldChg chg="del">
+        <pc:chgData name="Mohammed Fasha" userId="cc64f42d-a1a6-4f08-b97b-0c37f877119f" providerId="ADAL" clId="{BECD4A7F-C1AF-4585-8C31-FE7D4FE3ED16}" dt="2025-01-05T14:42:38.675" v="989" actId="2696"/>
+        <pc:sldMkLst>
+          <pc:docMk/>
+          <pc:sldMk cId="426516858" sldId="662"/>
+        </pc:sldMkLst>
+      </pc:sldChg>
+      <pc:sldChg chg="modSp add del mod">
+        <pc:chgData name="Mohammed Fasha" userId="cc64f42d-a1a6-4f08-b97b-0c37f877119f" providerId="ADAL" clId="{BECD4A7F-C1AF-4585-8C31-FE7D4FE3ED16}" dt="2025-01-05T16:34:59.233" v="1926" actId="20577"/>
+        <pc:sldMkLst>
+          <pc:docMk/>
+          <pc:sldMk cId="691538069" sldId="662"/>
+        </pc:sldMkLst>
+      </pc:sldChg>
+      <pc:sldChg chg="del">
+        <pc:chgData name="Mohammed Fasha" userId="cc64f42d-a1a6-4f08-b97b-0c37f877119f" providerId="ADAL" clId="{BECD4A7F-C1AF-4585-8C31-FE7D4FE3ED16}" dt="2025-01-05T14:42:38.675" v="989" actId="2696"/>
+        <pc:sldMkLst>
+          <pc:docMk/>
+          <pc:sldMk cId="895445062" sldId="663"/>
+        </pc:sldMkLst>
+      </pc:sldChg>
+      <pc:sldChg chg="add del">
+        <pc:chgData name="Mohammed Fasha" userId="cc64f42d-a1a6-4f08-b97b-0c37f877119f" providerId="ADAL" clId="{BECD4A7F-C1AF-4585-8C31-FE7D4FE3ED16}" dt="2025-01-05T14:43:16.100" v="993" actId="2696"/>
+        <pc:sldMkLst>
+          <pc:docMk/>
+          <pc:sldMk cId="3980180774" sldId="663"/>
+        </pc:sldMkLst>
+      </pc:sldChg>
+      <pc:sldChg chg="add del">
+        <pc:chgData name="Mohammed Fasha" userId="cc64f42d-a1a6-4f08-b97b-0c37f877119f" providerId="ADAL" clId="{BECD4A7F-C1AF-4585-8C31-FE7D4FE3ED16}" dt="2025-01-05T14:43:16.100" v="993" actId="2696"/>
+        <pc:sldMkLst>
+          <pc:docMk/>
+          <pc:sldMk cId="1728680596" sldId="664"/>
+        </pc:sldMkLst>
+      </pc:sldChg>
+      <pc:sldChg chg="del">
+        <pc:chgData name="Mohammed Fasha" userId="cc64f42d-a1a6-4f08-b97b-0c37f877119f" providerId="ADAL" clId="{BECD4A7F-C1AF-4585-8C31-FE7D4FE3ED16}" dt="2025-01-05T14:42:38.675" v="989" actId="2696"/>
+        <pc:sldMkLst>
+          <pc:docMk/>
+          <pc:sldMk cId="3900588277" sldId="664"/>
+        </pc:sldMkLst>
+      </pc:sldChg>
+      <pc:sldChg chg="del">
+        <pc:chgData name="Mohammed Fasha" userId="cc64f42d-a1a6-4f08-b97b-0c37f877119f" providerId="ADAL" clId="{BECD4A7F-C1AF-4585-8C31-FE7D4FE3ED16}" dt="2025-01-05T14:42:38.675" v="989" actId="2696"/>
+        <pc:sldMkLst>
+          <pc:docMk/>
+          <pc:sldMk cId="123002105" sldId="665"/>
+        </pc:sldMkLst>
+      </pc:sldChg>
+      <pc:sldChg chg="modSp add del mod">
+        <pc:chgData name="Mohammed Fasha" userId="cc64f42d-a1a6-4f08-b97b-0c37f877119f" providerId="ADAL" clId="{BECD4A7F-C1AF-4585-8C31-FE7D4FE3ED16}" dt="2025-01-05T15:05:12.729" v="1226" actId="21"/>
+        <pc:sldMkLst>
+          <pc:docMk/>
+          <pc:sldMk cId="148099094" sldId="665"/>
+        </pc:sldMkLst>
+      </pc:sldChg>
+      <pc:sldChg chg="del">
+        <pc:chgData name="Mohammed Fasha" userId="cc64f42d-a1a6-4f08-b97b-0c37f877119f" providerId="ADAL" clId="{BECD4A7F-C1AF-4585-8C31-FE7D4FE3ED16}" dt="2025-01-05T14:42:38.675" v="989" actId="2696"/>
+        <pc:sldMkLst>
+          <pc:docMk/>
+          <pc:sldMk cId="659863378" sldId="676"/>
+        </pc:sldMkLst>
+      </pc:sldChg>
+      <pc:sldChg chg="modSp add del mod">
+        <pc:chgData name="Mohammed Fasha" userId="cc64f42d-a1a6-4f08-b97b-0c37f877119f" providerId="ADAL" clId="{BECD4A7F-C1AF-4585-8C31-FE7D4FE3ED16}" dt="2025-01-05T14:55:27.595" v="1130" actId="255"/>
+        <pc:sldMkLst>
+          <pc:docMk/>
+          <pc:sldMk cId="1577854815" sldId="676"/>
+        </pc:sldMkLst>
+      </pc:sldChg>
+      <pc:sldChg chg="modSp add del mod">
+        <pc:chgData name="Mohammed Fasha" userId="cc64f42d-a1a6-4f08-b97b-0c37f877119f" providerId="ADAL" clId="{BECD4A7F-C1AF-4585-8C31-FE7D4FE3ED16}" dt="2025-01-05T14:55:43.754" v="1132" actId="1076"/>
+        <pc:sldMkLst>
+          <pc:docMk/>
+          <pc:sldMk cId="139882925" sldId="677"/>
+        </pc:sldMkLst>
+      </pc:sldChg>
+      <pc:sldChg chg="del">
+        <pc:chgData name="Mohammed Fasha" userId="cc64f42d-a1a6-4f08-b97b-0c37f877119f" providerId="ADAL" clId="{BECD4A7F-C1AF-4585-8C31-FE7D4FE3ED16}" dt="2025-01-05T14:42:38.675" v="989" actId="2696"/>
+        <pc:sldMkLst>
+          <pc:docMk/>
+          <pc:sldMk cId="2736863534" sldId="677"/>
+        </pc:sldMkLst>
+      </pc:sldChg>
+      <pc:sldChg chg="add del">
+        <pc:chgData name="Mohammed Fasha" userId="cc64f42d-a1a6-4f08-b97b-0c37f877119f" providerId="ADAL" clId="{BECD4A7F-C1AF-4585-8C31-FE7D4FE3ED16}" dt="2025-01-05T14:43:16.100" v="993" actId="2696"/>
+        <pc:sldMkLst>
+          <pc:docMk/>
+          <pc:sldMk cId="4146654093" sldId="678"/>
+        </pc:sldMkLst>
+      </pc:sldChg>
+      <pc:sldChg chg="del">
+        <pc:chgData name="Mohammed Fasha" userId="cc64f42d-a1a6-4f08-b97b-0c37f877119f" providerId="ADAL" clId="{BECD4A7F-C1AF-4585-8C31-FE7D4FE3ED16}" dt="2025-01-05T14:42:38.675" v="989" actId="2696"/>
+        <pc:sldMkLst>
+          <pc:docMk/>
+          <pc:sldMk cId="4228312762" sldId="678"/>
+        </pc:sldMkLst>
+      </pc:sldChg>
+      <pc:sldChg chg="del">
+        <pc:chgData name="Mohammed Fasha" userId="cc64f42d-a1a6-4f08-b97b-0c37f877119f" providerId="ADAL" clId="{BECD4A7F-C1AF-4585-8C31-FE7D4FE3ED16}" dt="2025-01-05T14:42:38.675" v="989" actId="2696"/>
+        <pc:sldMkLst>
+          <pc:docMk/>
+          <pc:sldMk cId="581717462" sldId="679"/>
+        </pc:sldMkLst>
+      </pc:sldChg>
+      <pc:sldChg chg="addSp delSp modSp add del mod chgLayout">
+        <pc:chgData name="Mohammed Fasha" userId="cc64f42d-a1a6-4f08-b97b-0c37f877119f" providerId="ADAL" clId="{BECD4A7F-C1AF-4585-8C31-FE7D4FE3ED16}" dt="2025-01-05T16:36:16.605" v="1945" actId="1076"/>
+        <pc:sldMkLst>
+          <pc:docMk/>
+          <pc:sldMk cId="3454522070" sldId="679"/>
+        </pc:sldMkLst>
+      </pc:sldChg>
+      <pc:sldChg chg="add del">
+        <pc:chgData name="Mohammed Fasha" userId="cc64f42d-a1a6-4f08-b97b-0c37f877119f" providerId="ADAL" clId="{BECD4A7F-C1AF-4585-8C31-FE7D4FE3ED16}" dt="2025-01-05T14:43:16.100" v="993" actId="2696"/>
+        <pc:sldMkLst>
+          <pc:docMk/>
+          <pc:sldMk cId="2856814121" sldId="681"/>
+        </pc:sldMkLst>
+      </pc:sldChg>
+      <pc:sldChg chg="del">
+        <pc:chgData name="Mohammed Fasha" userId="cc64f42d-a1a6-4f08-b97b-0c37f877119f" providerId="ADAL" clId="{BECD4A7F-C1AF-4585-8C31-FE7D4FE3ED16}" dt="2025-01-05T14:42:38.675" v="989" actId="2696"/>
+        <pc:sldMkLst>
+          <pc:docMk/>
+          <pc:sldMk cId="3083966018" sldId="681"/>
+        </pc:sldMkLst>
+      </pc:sldChg>
+      <pc:sldChg chg="modSp mod">
+        <pc:chgData name="Mohammed Fasha" userId="cc64f42d-a1a6-4f08-b97b-0c37f877119f" providerId="ADAL" clId="{BECD4A7F-C1AF-4585-8C31-FE7D4FE3ED16}" dt="2025-01-05T14:42:50.596" v="990" actId="14100"/>
+        <pc:sldMkLst>
+          <pc:docMk/>
+          <pc:sldMk cId="1697141369" sldId="695"/>
+        </pc:sldMkLst>
+      </pc:sldChg>
+      <pc:sldChg chg="addSp delSp modSp add del mod">
+        <pc:chgData name="Mohammed Fasha" userId="cc64f42d-a1a6-4f08-b97b-0c37f877119f" providerId="ADAL" clId="{BECD4A7F-C1AF-4585-8C31-FE7D4FE3ED16}" dt="2025-01-05T14:54:31.375" v="1125" actId="14100"/>
+        <pc:sldMkLst>
+          <pc:docMk/>
+          <pc:sldMk cId="265576630" sldId="698"/>
+        </pc:sldMkLst>
+      </pc:sldChg>
+      <pc:sldChg chg="del">
+        <pc:chgData name="Mohammed Fasha" userId="cc64f42d-a1a6-4f08-b97b-0c37f877119f" providerId="ADAL" clId="{BECD4A7F-C1AF-4585-8C31-FE7D4FE3ED16}" dt="2025-01-05T14:42:38.675" v="989" actId="2696"/>
+        <pc:sldMkLst>
+          <pc:docMk/>
+          <pc:sldMk cId="991725834" sldId="698"/>
+        </pc:sldMkLst>
+      </pc:sldChg>
+      <pc:sldChg chg="del">
+        <pc:chgData name="Mohammed Fasha" userId="cc64f42d-a1a6-4f08-b97b-0c37f877119f" providerId="ADAL" clId="{BECD4A7F-C1AF-4585-8C31-FE7D4FE3ED16}" dt="2025-01-05T14:42:38.675" v="989" actId="2696"/>
+        <pc:sldMkLst>
+          <pc:docMk/>
+          <pc:sldMk cId="3109561867" sldId="700"/>
+        </pc:sldMkLst>
+      </pc:sldChg>
+      <pc:sldChg chg="addSp delSp modSp add del mod">
+        <pc:chgData name="Mohammed Fasha" userId="cc64f42d-a1a6-4f08-b97b-0c37f877119f" providerId="ADAL" clId="{BECD4A7F-C1AF-4585-8C31-FE7D4FE3ED16}" dt="2025-01-05T16:00:05.564" v="1529" actId="20577"/>
+        <pc:sldMkLst>
+          <pc:docMk/>
+          <pc:sldMk cId="4247717824" sldId="700"/>
+        </pc:sldMkLst>
+      </pc:sldChg>
+      <pc:sldChg chg="addSp delSp modSp add mod">
+        <pc:chgData name="Mohammed Fasha" userId="cc64f42d-a1a6-4f08-b97b-0c37f877119f" providerId="ADAL" clId="{BECD4A7F-C1AF-4585-8C31-FE7D4FE3ED16}" dt="2025-01-05T14:53:29.185" v="1101" actId="21"/>
+        <pc:sldMkLst>
+          <pc:docMk/>
+          <pc:sldMk cId="67871309" sldId="709"/>
+        </pc:sldMkLst>
+      </pc:sldChg>
+      <pc:sldChg chg="modSp add mod">
+        <pc:chgData name="Mohammed Fasha" userId="cc64f42d-a1a6-4f08-b97b-0c37f877119f" providerId="ADAL" clId="{BECD4A7F-C1AF-4585-8C31-FE7D4FE3ED16}" dt="2025-01-05T15:31:09.113" v="1385" actId="6549"/>
+        <pc:sldMkLst>
+          <pc:docMk/>
+          <pc:sldMk cId="4114896152" sldId="710"/>
+        </pc:sldMkLst>
+      </pc:sldChg>
+      <pc:sldChg chg="addSp modSp add mod">
+        <pc:chgData name="Mohammed Fasha" userId="cc64f42d-a1a6-4f08-b97b-0c37f877119f" providerId="ADAL" clId="{BECD4A7F-C1AF-4585-8C31-FE7D4FE3ED16}" dt="2025-01-05T15:27:36.027" v="1348" actId="20577"/>
+        <pc:sldMkLst>
+          <pc:docMk/>
+          <pc:sldMk cId="3794385322" sldId="711"/>
+        </pc:sldMkLst>
+      </pc:sldChg>
+      <pc:sldChg chg="add del">
+        <pc:chgData name="Mohammed Fasha" userId="cc64f42d-a1a6-4f08-b97b-0c37f877119f" providerId="ADAL" clId="{BECD4A7F-C1AF-4585-8C31-FE7D4FE3ED16}" dt="2025-01-05T14:57:43.613" v="1146" actId="2696"/>
+        <pc:sldMkLst>
+          <pc:docMk/>
+          <pc:sldMk cId="501127302" sldId="712"/>
+        </pc:sldMkLst>
+      </pc:sldChg>
+      <pc:sldChg chg="modSp add mod">
+        <pc:chgData name="Mohammed Fasha" userId="cc64f42d-a1a6-4f08-b97b-0c37f877119f" providerId="ADAL" clId="{BECD4A7F-C1AF-4585-8C31-FE7D4FE3ED16}" dt="2025-01-05T15:32:23.870" v="1388"/>
+        <pc:sldMkLst>
+          <pc:docMk/>
+          <pc:sldMk cId="3701206727" sldId="712"/>
+        </pc:sldMkLst>
+      </pc:sldChg>
+      <pc:sldChg chg="addSp modSp add mod">
+        <pc:chgData name="Mohammed Fasha" userId="cc64f42d-a1a6-4f08-b97b-0c37f877119f" providerId="ADAL" clId="{BECD4A7F-C1AF-4585-8C31-FE7D4FE3ED16}" dt="2025-01-05T16:06:36.028" v="1538" actId="1076"/>
+        <pc:sldMkLst>
+          <pc:docMk/>
+          <pc:sldMk cId="1499972066" sldId="713"/>
+        </pc:sldMkLst>
+      </pc:sldChg>
+      <pc:sldChg chg="addSp delSp modSp add mod">
+        <pc:chgData name="Mohammed Fasha" userId="cc64f42d-a1a6-4f08-b97b-0c37f877119f" providerId="ADAL" clId="{BECD4A7F-C1AF-4585-8C31-FE7D4FE3ED16}" dt="2025-01-05T16:19:08.436" v="1705" actId="1036"/>
+        <pc:sldMkLst>
+          <pc:docMk/>
+          <pc:sldMk cId="1270641495" sldId="714"/>
+        </pc:sldMkLst>
+      </pc:sldChg>
+      <pc:sldChg chg="addSp modSp new mod">
+        <pc:chgData name="Mohammed Fasha" userId="cc64f42d-a1a6-4f08-b97b-0c37f877119f" providerId="ADAL" clId="{BECD4A7F-C1AF-4585-8C31-FE7D4FE3ED16}" dt="2025-01-05T16:23:44.632" v="1736" actId="12"/>
+        <pc:sldMkLst>
+          <pc:docMk/>
+          <pc:sldMk cId="1096386322" sldId="715"/>
+        </pc:sldMkLst>
+      </pc:sldChg>
+      <pc:sldChg chg="modSp new mod">
+        <pc:chgData name="Mohammed Fasha" userId="cc64f42d-a1a6-4f08-b97b-0c37f877119f" providerId="ADAL" clId="{BECD4A7F-C1AF-4585-8C31-FE7D4FE3ED16}" dt="2025-01-05T16:34:02.360" v="1902" actId="27636"/>
+        <pc:sldMkLst>
+          <pc:docMk/>
+          <pc:sldMk cId="1784058309" sldId="716"/>
+        </pc:sldMkLst>
+      </pc:sldChg>
+      <pc:sldChg chg="modSp add mod ord">
+        <pc:chgData name="Mohammed Fasha" userId="cc64f42d-a1a6-4f08-b97b-0c37f877119f" providerId="ADAL" clId="{BECD4A7F-C1AF-4585-8C31-FE7D4FE3ED16}" dt="2025-01-05T16:27:20.520" v="1803"/>
+        <pc:sldMkLst>
+          <pc:docMk/>
+          <pc:sldMk cId="3139017106" sldId="717"/>
+        </pc:sldMkLst>
+      </pc:sldChg>
+      <pc:sldChg chg="addSp delSp modSp new mod">
+        <pc:chgData name="Mohammed Fasha" userId="cc64f42d-a1a6-4f08-b97b-0c37f877119f" providerId="ADAL" clId="{BECD4A7F-C1AF-4585-8C31-FE7D4FE3ED16}" dt="2025-01-05T16:32:45.446" v="1897" actId="20577"/>
+        <pc:sldMkLst>
+          <pc:docMk/>
+          <pc:sldMk cId="3043812923" sldId="718"/>
+        </pc:sldMkLst>
+      </pc:sldChg>
+    </pc:docChg>
+  </pc:docChgLst>
   <pc:docChgLst>
     <pc:chgData name="Mohammed Fasha" userId="cc64f42d-a1a6-4f08-b97b-0c37f877119f" providerId="ADAL" clId="{18637E31-0E18-4A5A-AC68-AF9D3439D974}"/>
     <pc:docChg chg="undo custSel delSld modSld sldOrd">
@@ -255,6 +524,36 @@
             <ac:spMk id="3" creationId="{8AEDF9A6-3E2A-ECD5-AC94-898AAFEDC346}"/>
           </ac:spMkLst>
         </pc:spChg>
+      </pc:sldChg>
+    </pc:docChg>
+  </pc:docChgLst>
+  <pc:docChgLst>
+    <pc:chgData name="Mohammed Fasha" userId="cc64f42d-a1a6-4f08-b97b-0c37f877119f" providerId="ADAL" clId="{4C71ED24-115E-432D-933D-C801DA3E52F1}"/>
+    <pc:docChg chg="delSld">
+      <pc:chgData name="Mohammed Fasha" userId="cc64f42d-a1a6-4f08-b97b-0c37f877119f" providerId="ADAL" clId="{4C71ED24-115E-432D-933D-C801DA3E52F1}" dt="2024-12-29T03:12:49.974" v="2" actId="47"/>
+      <pc:docMkLst>
+        <pc:docMk/>
+      </pc:docMkLst>
+      <pc:sldChg chg="del">
+        <pc:chgData name="Mohammed Fasha" userId="cc64f42d-a1a6-4f08-b97b-0c37f877119f" providerId="ADAL" clId="{4C71ED24-115E-432D-933D-C801DA3E52F1}" dt="2024-12-29T03:12:48.360" v="0" actId="47"/>
+        <pc:sldMkLst>
+          <pc:docMk/>
+          <pc:sldMk cId="2341000601" sldId="701"/>
+        </pc:sldMkLst>
+      </pc:sldChg>
+      <pc:sldChg chg="del">
+        <pc:chgData name="Mohammed Fasha" userId="cc64f42d-a1a6-4f08-b97b-0c37f877119f" providerId="ADAL" clId="{4C71ED24-115E-432D-933D-C801DA3E52F1}" dt="2024-12-29T03:12:49.133" v="1" actId="47"/>
+        <pc:sldMkLst>
+          <pc:docMk/>
+          <pc:sldMk cId="3519698944" sldId="702"/>
+        </pc:sldMkLst>
+      </pc:sldChg>
+      <pc:sldChg chg="del">
+        <pc:chgData name="Mohammed Fasha" userId="cc64f42d-a1a6-4f08-b97b-0c37f877119f" providerId="ADAL" clId="{4C71ED24-115E-432D-933D-C801DA3E52F1}" dt="2024-12-29T03:12:49.974" v="2" actId="47"/>
+        <pc:sldMkLst>
+          <pc:docMk/>
+          <pc:sldMk cId="3934257344" sldId="703"/>
+        </pc:sldMkLst>
       </pc:sldChg>
     </pc:docChg>
   </pc:docChgLst>
@@ -1845,6 +2144,139 @@
     </pc:docChg>
   </pc:docChgLst>
   <pc:docChgLst>
+    <pc:chgData name="Mohammed Fasha" userId="cc64f42d-a1a6-4f08-b97b-0c37f877119f" providerId="ADAL" clId="{2E5FBF59-3168-4932-9518-582502FE1AD5}"/>
+    <pc:docChg chg="undo custSel delSld modSld">
+      <pc:chgData name="Mohammed Fasha" userId="cc64f42d-a1a6-4f08-b97b-0c37f877119f" providerId="ADAL" clId="{2E5FBF59-3168-4932-9518-582502FE1AD5}" dt="2024-12-24T08:08:19.987" v="550" actId="20577"/>
+      <pc:docMkLst>
+        <pc:docMk/>
+      </pc:docMkLst>
+      <pc:sldChg chg="delSp">
+        <pc:chgData name="Mohammed Fasha" userId="cc64f42d-a1a6-4f08-b97b-0c37f877119f" providerId="ADAL" clId="{2E5FBF59-3168-4932-9518-582502FE1AD5}" dt="2024-11-19T07:40:47.121" v="208" actId="478"/>
+        <pc:sldMkLst>
+          <pc:docMk/>
+          <pc:sldMk cId="391491219" sldId="428"/>
+        </pc:sldMkLst>
+      </pc:sldChg>
+      <pc:sldChg chg="modSp">
+        <pc:chgData name="Mohammed Fasha" userId="cc64f42d-a1a6-4f08-b97b-0c37f877119f" providerId="ADAL" clId="{2E5FBF59-3168-4932-9518-582502FE1AD5}" dt="2024-12-03T07:43:58.007" v="456" actId="1076"/>
+        <pc:sldMkLst>
+          <pc:docMk/>
+          <pc:sldMk cId="3339445507" sldId="430"/>
+        </pc:sldMkLst>
+      </pc:sldChg>
+      <pc:sldChg chg="modSp">
+        <pc:chgData name="Mohammed Fasha" userId="cc64f42d-a1a6-4f08-b97b-0c37f877119f" providerId="ADAL" clId="{2E5FBF59-3168-4932-9518-582502FE1AD5}" dt="2024-12-03T07:45:08.136" v="474" actId="20577"/>
+        <pc:sldMkLst>
+          <pc:docMk/>
+          <pc:sldMk cId="3389046835" sldId="431"/>
+        </pc:sldMkLst>
+      </pc:sldChg>
+      <pc:sldChg chg="modSp">
+        <pc:chgData name="Mohammed Fasha" userId="cc64f42d-a1a6-4f08-b97b-0c37f877119f" providerId="ADAL" clId="{2E5FBF59-3168-4932-9518-582502FE1AD5}" dt="2024-11-10T06:33:09.727" v="37" actId="207"/>
+        <pc:sldMkLst>
+          <pc:docMk/>
+          <pc:sldMk cId="2726994946" sldId="479"/>
+        </pc:sldMkLst>
+      </pc:sldChg>
+      <pc:sldChg chg="modSp">
+        <pc:chgData name="Mohammed Fasha" userId="cc64f42d-a1a6-4f08-b97b-0c37f877119f" providerId="ADAL" clId="{2E5FBF59-3168-4932-9518-582502FE1AD5}" dt="2024-11-19T07:44:28.766" v="211" actId="20577"/>
+        <pc:sldMkLst>
+          <pc:docMk/>
+          <pc:sldMk cId="2297456757" sldId="483"/>
+        </pc:sldMkLst>
+      </pc:sldChg>
+      <pc:sldChg chg="modSp">
+        <pc:chgData name="Mohammed Fasha" userId="cc64f42d-a1a6-4f08-b97b-0c37f877119f" providerId="ADAL" clId="{2E5FBF59-3168-4932-9518-582502FE1AD5}" dt="2024-11-10T06:45:09.392" v="40" actId="20577"/>
+        <pc:sldMkLst>
+          <pc:docMk/>
+          <pc:sldMk cId="3474268344" sldId="596"/>
+        </pc:sldMkLst>
+      </pc:sldChg>
+      <pc:sldChg chg="modSp">
+        <pc:chgData name="Mohammed Fasha" userId="cc64f42d-a1a6-4f08-b97b-0c37f877119f" providerId="ADAL" clId="{2E5FBF59-3168-4932-9518-582502FE1AD5}" dt="2024-12-03T07:47:21.561" v="476" actId="6549"/>
+        <pc:sldMkLst>
+          <pc:docMk/>
+          <pc:sldMk cId="399592497" sldId="613"/>
+        </pc:sldMkLst>
+      </pc:sldChg>
+      <pc:sldChg chg="modSp">
+        <pc:chgData name="Mohammed Fasha" userId="cc64f42d-a1a6-4f08-b97b-0c37f877119f" providerId="ADAL" clId="{2E5FBF59-3168-4932-9518-582502FE1AD5}" dt="2024-12-03T07:49:02.980" v="478" actId="207"/>
+        <pc:sldMkLst>
+          <pc:docMk/>
+          <pc:sldMk cId="3329135496" sldId="617"/>
+        </pc:sldMkLst>
+      </pc:sldChg>
+      <pc:sldChg chg="modSp">
+        <pc:chgData name="Mohammed Fasha" userId="cc64f42d-a1a6-4f08-b97b-0c37f877119f" providerId="ADAL" clId="{2E5FBF59-3168-4932-9518-582502FE1AD5}" dt="2024-12-24T08:05:16.608" v="482" actId="403"/>
+        <pc:sldMkLst>
+          <pc:docMk/>
+          <pc:sldMk cId="2990045589" sldId="659"/>
+        </pc:sldMkLst>
+      </pc:sldChg>
+      <pc:sldChg chg="modSp">
+        <pc:chgData name="Mohammed Fasha" userId="cc64f42d-a1a6-4f08-b97b-0c37f877119f" providerId="ADAL" clId="{2E5FBF59-3168-4932-9518-582502FE1AD5}" dt="2024-12-24T08:08:19.987" v="550" actId="20577"/>
+        <pc:sldMkLst>
+          <pc:docMk/>
+          <pc:sldMk cId="2680231355" sldId="669"/>
+        </pc:sldMkLst>
+      </pc:sldChg>
+      <pc:sldChg chg="addSp modSp">
+        <pc:chgData name="Mohammed Fasha" userId="cc64f42d-a1a6-4f08-b97b-0c37f877119f" providerId="ADAL" clId="{2E5FBF59-3168-4932-9518-582502FE1AD5}" dt="2024-12-24T08:05:52.910" v="488" actId="1076"/>
+        <pc:sldMkLst>
+          <pc:docMk/>
+          <pc:sldMk cId="916102856" sldId="685"/>
+        </pc:sldMkLst>
+      </pc:sldChg>
+      <pc:sldChg chg="modSp">
+        <pc:chgData name="Mohammed Fasha" userId="cc64f42d-a1a6-4f08-b97b-0c37f877119f" providerId="ADAL" clId="{2E5FBF59-3168-4932-9518-582502FE1AD5}" dt="2024-11-19T07:03:29.557" v="206" actId="207"/>
+        <pc:sldMkLst>
+          <pc:docMk/>
+          <pc:sldMk cId="32004852" sldId="708"/>
+        </pc:sldMkLst>
+      </pc:sldChg>
+    </pc:docChg>
+  </pc:docChgLst>
+  <pc:docChgLst>
+    <pc:chgData name="Mohammed Fasha" userId="cc64f42d-a1a6-4f08-b97b-0c37f877119f" providerId="ADAL" clId="{5980B3BB-4EB6-4E37-92BF-3A2A8F4B2C7A}"/>
+    <pc:docChg chg="custSel modSld">
+      <pc:chgData name="Mohammed Fasha" userId="cc64f42d-a1a6-4f08-b97b-0c37f877119f" providerId="ADAL" clId="{5980B3BB-4EB6-4E37-92BF-3A2A8F4B2C7A}" dt="2024-10-15T02:28:13.535" v="0" actId="478"/>
+      <pc:docMkLst>
+        <pc:docMk/>
+      </pc:docMkLst>
+      <pc:sldChg chg="delSp mod">
+        <pc:chgData name="Mohammed Fasha" userId="cc64f42d-a1a6-4f08-b97b-0c37f877119f" providerId="ADAL" clId="{5980B3BB-4EB6-4E37-92BF-3A2A8F4B2C7A}" dt="2024-10-15T02:28:13.535" v="0" actId="478"/>
+        <pc:sldMkLst>
+          <pc:docMk/>
+          <pc:sldMk cId="2297456757" sldId="483"/>
+        </pc:sldMkLst>
+      </pc:sldChg>
+    </pc:docChg>
+  </pc:docChgLst>
+  <pc:docChgLst>
+    <pc:chgData name="Mohammed Fasha" userId="cc64f42d-a1a6-4f08-b97b-0c37f877119f" providerId="ADAL" clId="{6804A8E6-8D7F-46E3-B091-66A8F6B926BF}"/>
+    <pc:docChg chg="custSel modMainMaster">
+      <pc:chgData name="Mohammed Fasha" userId="cc64f42d-a1a6-4f08-b97b-0c37f877119f" providerId="ADAL" clId="{6804A8E6-8D7F-46E3-B091-66A8F6B926BF}" dt="2024-11-09T05:15:35.019" v="2" actId="1076"/>
+      <pc:docMkLst>
+        <pc:docMk/>
+      </pc:docMkLst>
+      <pc:sldMasterChg chg="delSp mod modSldLayout">
+        <pc:chgData name="Mohammed Fasha" userId="cc64f42d-a1a6-4f08-b97b-0c37f877119f" providerId="ADAL" clId="{6804A8E6-8D7F-46E3-B091-66A8F6B926BF}" dt="2024-11-09T05:15:35.019" v="2" actId="1076"/>
+        <pc:sldMasterMkLst>
+          <pc:docMk/>
+          <pc:sldMasterMk cId="742811419" sldId="2147483648"/>
+        </pc:sldMasterMkLst>
+        <pc:sldLayoutChg chg="addSp modSp mod">
+          <pc:chgData name="Mohammed Fasha" userId="cc64f42d-a1a6-4f08-b97b-0c37f877119f" providerId="ADAL" clId="{6804A8E6-8D7F-46E3-B091-66A8F6B926BF}" dt="2024-11-09T05:15:35.019" v="2" actId="1076"/>
+          <pc:sldLayoutMkLst>
+            <pc:docMk/>
+            <pc:sldMasterMk cId="742811419" sldId="2147483648"/>
+            <pc:sldLayoutMk cId="4063788262" sldId="2147483649"/>
+          </pc:sldLayoutMkLst>
+        </pc:sldLayoutChg>
+      </pc:sldMasterChg>
+    </pc:docChg>
+  </pc:docChgLst>
+  <pc:docChgLst>
     <pc:chgData name="Mohammed Fasha" userId="cc64f42d-a1a6-4f08-b97b-0c37f877119f" providerId="ADAL" clId="{1430C6B2-0695-4939-9A81-7D403BE3894B}"/>
     <pc:docChg chg="undo redo custSel addSld delSld modSld">
       <pc:chgData name="Mohammed Fasha" userId="cc64f42d-a1a6-4f08-b97b-0c37f877119f" providerId="ADAL" clId="{1430C6B2-0695-4939-9A81-7D403BE3894B}" dt="2025-04-06T04:27:46.978" v="903" actId="2696"/>
@@ -2725,434 +3157,203 @@
     </pc:docChg>
   </pc:docChgLst>
   <pc:docChgLst>
-    <pc:chgData name="Mohammed Fasha" userId="cc64f42d-a1a6-4f08-b97b-0c37f877119f" providerId="ADAL" clId="{5980B3BB-4EB6-4E37-92BF-3A2A8F4B2C7A}"/>
-    <pc:docChg chg="custSel modSld">
-      <pc:chgData name="Mohammed Fasha" userId="cc64f42d-a1a6-4f08-b97b-0c37f877119f" providerId="ADAL" clId="{5980B3BB-4EB6-4E37-92BF-3A2A8F4B2C7A}" dt="2024-10-15T02:28:13.535" v="0" actId="478"/>
+    <pc:chgData name="Mohammed Fasha" userId="S::mohammed.fasha@uop.edu.jo::cc64f42d-a1a6-4f08-b97b-0c37f877119f" providerId="AD" clId="Web-{9DEFE369-4FE8-C0FA-AE89-88E89C96B65F}"/>
+    <pc:docChg chg="modSld">
+      <pc:chgData name="Mohammed Fasha" userId="S::mohammed.fasha@uop.edu.jo::cc64f42d-a1a6-4f08-b97b-0c37f877119f" providerId="AD" clId="Web-{9DEFE369-4FE8-C0FA-AE89-88E89C96B65F}" dt="2025-04-07T19:02:15.269" v="50" actId="1076"/>
       <pc:docMkLst>
         <pc:docMk/>
       </pc:docMkLst>
-      <pc:sldChg chg="delSp mod">
-        <pc:chgData name="Mohammed Fasha" userId="cc64f42d-a1a6-4f08-b97b-0c37f877119f" providerId="ADAL" clId="{5980B3BB-4EB6-4E37-92BF-3A2A8F4B2C7A}" dt="2024-10-15T02:28:13.535" v="0" actId="478"/>
+      <pc:sldChg chg="modSp">
+        <pc:chgData name="Mohammed Fasha" userId="S::mohammed.fasha@uop.edu.jo::cc64f42d-a1a6-4f08-b97b-0c37f877119f" providerId="AD" clId="Web-{9DEFE369-4FE8-C0FA-AE89-88E89C96B65F}" dt="2025-04-07T19:02:15.269" v="50" actId="1076"/>
         <pc:sldMkLst>
           <pc:docMk/>
-          <pc:sldMk cId="2297456757" sldId="483"/>
+          <pc:sldMk cId="0" sldId="264"/>
         </pc:sldMkLst>
+        <pc:picChg chg="mod">
+          <ac:chgData name="Mohammed Fasha" userId="S::mohammed.fasha@uop.edu.jo::cc64f42d-a1a6-4f08-b97b-0c37f877119f" providerId="AD" clId="Web-{9DEFE369-4FE8-C0FA-AE89-88E89C96B65F}" dt="2025-04-07T19:02:15.269" v="50" actId="1076"/>
+          <ac:picMkLst>
+            <pc:docMk/>
+            <pc:sldMk cId="0" sldId="264"/>
+            <ac:picMk id="115" creationId="{00000000-0000-0000-0000-000000000000}"/>
+          </ac:picMkLst>
+        </pc:picChg>
       </pc:sldChg>
-    </pc:docChg>
-  </pc:docChgLst>
-  <pc:docChgLst>
-    <pc:chgData name="Mohammed Fasha" userId="cc64f42d-a1a6-4f08-b97b-0c37f877119f" providerId="ADAL" clId="{4C71ED24-115E-432D-933D-C801DA3E52F1}"/>
-    <pc:docChg chg="delSld">
-      <pc:chgData name="Mohammed Fasha" userId="cc64f42d-a1a6-4f08-b97b-0c37f877119f" providerId="ADAL" clId="{4C71ED24-115E-432D-933D-C801DA3E52F1}" dt="2024-12-29T03:12:49.974" v="2" actId="47"/>
-      <pc:docMkLst>
-        <pc:docMk/>
-      </pc:docMkLst>
-      <pc:sldChg chg="del">
-        <pc:chgData name="Mohammed Fasha" userId="cc64f42d-a1a6-4f08-b97b-0c37f877119f" providerId="ADAL" clId="{4C71ED24-115E-432D-933D-C801DA3E52F1}" dt="2024-12-29T03:12:48.360" v="0" actId="47"/>
+      <pc:sldChg chg="modSp">
+        <pc:chgData name="Mohammed Fasha" userId="S::mohammed.fasha@uop.edu.jo::cc64f42d-a1a6-4f08-b97b-0c37f877119f" providerId="AD" clId="Web-{9DEFE369-4FE8-C0FA-AE89-88E89C96B65F}" dt="2025-04-07T19:02:08.988" v="49" actId="1076"/>
         <pc:sldMkLst>
           <pc:docMk/>
-          <pc:sldMk cId="2341000601" sldId="701"/>
+          <pc:sldMk cId="0" sldId="265"/>
         </pc:sldMkLst>
+        <pc:picChg chg="mod">
+          <ac:chgData name="Mohammed Fasha" userId="S::mohammed.fasha@uop.edu.jo::cc64f42d-a1a6-4f08-b97b-0c37f877119f" providerId="AD" clId="Web-{9DEFE369-4FE8-C0FA-AE89-88E89C96B65F}" dt="2025-04-07T19:02:08.988" v="49" actId="1076"/>
+          <ac:picMkLst>
+            <pc:docMk/>
+            <pc:sldMk cId="0" sldId="265"/>
+            <ac:picMk id="3" creationId="{68EA6CB0-BFE2-482A-D045-9E2274E13790}"/>
+          </ac:picMkLst>
+        </pc:picChg>
       </pc:sldChg>
-      <pc:sldChg chg="del">
-        <pc:chgData name="Mohammed Fasha" userId="cc64f42d-a1a6-4f08-b97b-0c37f877119f" providerId="ADAL" clId="{4C71ED24-115E-432D-933D-C801DA3E52F1}" dt="2024-12-29T03:12:49.133" v="1" actId="47"/>
+      <pc:sldChg chg="modSp">
+        <pc:chgData name="Mohammed Fasha" userId="S::mohammed.fasha@uop.edu.jo::cc64f42d-a1a6-4f08-b97b-0c37f877119f" providerId="AD" clId="Web-{9DEFE369-4FE8-C0FA-AE89-88E89C96B65F}" dt="2025-04-07T19:02:02.675" v="48" actId="1076"/>
         <pc:sldMkLst>
           <pc:docMk/>
-          <pc:sldMk cId="3519698944" sldId="702"/>
+          <pc:sldMk cId="0" sldId="266"/>
         </pc:sldMkLst>
+        <pc:picChg chg="mod">
+          <ac:chgData name="Mohammed Fasha" userId="S::mohammed.fasha@uop.edu.jo::cc64f42d-a1a6-4f08-b97b-0c37f877119f" providerId="AD" clId="Web-{9DEFE369-4FE8-C0FA-AE89-88E89C96B65F}" dt="2025-04-07T19:02:02.675" v="48" actId="1076"/>
+          <ac:picMkLst>
+            <pc:docMk/>
+            <pc:sldMk cId="0" sldId="266"/>
+            <ac:picMk id="3" creationId="{53D1A3D5-A337-E152-A2D3-43439D59A1BE}"/>
+          </ac:picMkLst>
+        </pc:picChg>
       </pc:sldChg>
-      <pc:sldChg chg="del">
-        <pc:chgData name="Mohammed Fasha" userId="cc64f42d-a1a6-4f08-b97b-0c37f877119f" providerId="ADAL" clId="{4C71ED24-115E-432D-933D-C801DA3E52F1}" dt="2024-12-29T03:12:49.974" v="2" actId="47"/>
+      <pc:sldChg chg="modSp">
+        <pc:chgData name="Mohammed Fasha" userId="S::mohammed.fasha@uop.edu.jo::cc64f42d-a1a6-4f08-b97b-0c37f877119f" providerId="AD" clId="Web-{9DEFE369-4FE8-C0FA-AE89-88E89C96B65F}" dt="2025-04-07T19:01:55.612" v="47" actId="1076"/>
         <pc:sldMkLst>
           <pc:docMk/>
-          <pc:sldMk cId="3934257344" sldId="703"/>
+          <pc:sldMk cId="0" sldId="270"/>
         </pc:sldMkLst>
+        <pc:picChg chg="mod">
+          <ac:chgData name="Mohammed Fasha" userId="S::mohammed.fasha@uop.edu.jo::cc64f42d-a1a6-4f08-b97b-0c37f877119f" providerId="AD" clId="Web-{9DEFE369-4FE8-C0FA-AE89-88E89C96B65F}" dt="2025-04-07T19:01:55.612" v="47" actId="1076"/>
+          <ac:picMkLst>
+            <pc:docMk/>
+            <pc:sldMk cId="0" sldId="270"/>
+            <ac:picMk id="3" creationId="{E9501D06-4E28-42B8-54EC-6C48C4567DB7}"/>
+          </ac:picMkLst>
+        </pc:picChg>
       </pc:sldChg>
-    </pc:docChg>
-  </pc:docChgLst>
-  <pc:docChgLst>
-    <pc:chgData name="Mohammed Fasha" userId="cc64f42d-a1a6-4f08-b97b-0c37f877119f" providerId="ADAL" clId="{BECD4A7F-C1AF-4585-8C31-FE7D4FE3ED16}"/>
-    <pc:docChg chg="undo redo custSel addSld delSld modSld sldOrd">
-      <pc:chgData name="Mohammed Fasha" userId="cc64f42d-a1a6-4f08-b97b-0c37f877119f" providerId="ADAL" clId="{BECD4A7F-C1AF-4585-8C31-FE7D4FE3ED16}" dt="2025-01-05T16:36:16.605" v="1945" actId="1076"/>
-      <pc:docMkLst>
-        <pc:docMk/>
-      </pc:docMkLst>
-      <pc:sldChg chg="modSp mod">
-        <pc:chgData name="Mohammed Fasha" userId="cc64f42d-a1a6-4f08-b97b-0c37f877119f" providerId="ADAL" clId="{BECD4A7F-C1AF-4585-8C31-FE7D4FE3ED16}" dt="2024-12-30T18:47:27.683" v="988" actId="20577"/>
+      <pc:sldChg chg="modSp">
+        <pc:chgData name="Mohammed Fasha" userId="S::mohammed.fasha@uop.edu.jo::cc64f42d-a1a6-4f08-b97b-0c37f877119f" providerId="AD" clId="Web-{9DEFE369-4FE8-C0FA-AE89-88E89C96B65F}" dt="2025-04-07T19:01:49.472" v="46" actId="1076"/>
         <pc:sldMkLst>
           <pc:docMk/>
-          <pc:sldMk cId="2281221656" sldId="527"/>
+          <pc:sldMk cId="0" sldId="274"/>
         </pc:sldMkLst>
+        <pc:picChg chg="mod">
+          <ac:chgData name="Mohammed Fasha" userId="S::mohammed.fasha@uop.edu.jo::cc64f42d-a1a6-4f08-b97b-0c37f877119f" providerId="AD" clId="Web-{9DEFE369-4FE8-C0FA-AE89-88E89C96B65F}" dt="2025-04-07T19:01:49.472" v="46" actId="1076"/>
+          <ac:picMkLst>
+            <pc:docMk/>
+            <pc:sldMk cId="0" sldId="274"/>
+            <ac:picMk id="3" creationId="{2137DE1E-E18E-A534-77E6-28A80EF44BD2}"/>
+          </ac:picMkLst>
+        </pc:picChg>
       </pc:sldChg>
-      <pc:sldChg chg="modSp mod">
-        <pc:chgData name="Mohammed Fasha" userId="cc64f42d-a1a6-4f08-b97b-0c37f877119f" providerId="ADAL" clId="{BECD4A7F-C1AF-4585-8C31-FE7D4FE3ED16}" dt="2024-12-27T13:59:26.893" v="366" actId="20577"/>
+      <pc:sldChg chg="modSp">
+        <pc:chgData name="Mohammed Fasha" userId="S::mohammed.fasha@uop.edu.jo::cc64f42d-a1a6-4f08-b97b-0c37f877119f" providerId="AD" clId="Web-{9DEFE369-4FE8-C0FA-AE89-88E89C96B65F}" dt="2025-04-07T19:01:39.424" v="45" actId="1076"/>
         <pc:sldMkLst>
           <pc:docMk/>
-          <pc:sldMk cId="3474268344" sldId="596"/>
+          <pc:sldMk cId="0" sldId="277"/>
         </pc:sldMkLst>
+        <pc:picChg chg="mod">
+          <ac:chgData name="Mohammed Fasha" userId="S::mohammed.fasha@uop.edu.jo::cc64f42d-a1a6-4f08-b97b-0c37f877119f" providerId="AD" clId="Web-{9DEFE369-4FE8-C0FA-AE89-88E89C96B65F}" dt="2025-04-07T19:01:39.424" v="45" actId="1076"/>
+          <ac:picMkLst>
+            <pc:docMk/>
+            <pc:sldMk cId="0" sldId="277"/>
+            <ac:picMk id="3" creationId="{12B2D59F-BB12-6EC1-7754-F99FB98DC6B1}"/>
+          </ac:picMkLst>
+        </pc:picChg>
       </pc:sldChg>
-      <pc:sldChg chg="modSp mod">
-        <pc:chgData name="Mohammed Fasha" userId="cc64f42d-a1a6-4f08-b97b-0c37f877119f" providerId="ADAL" clId="{BECD4A7F-C1AF-4585-8C31-FE7D4FE3ED16}" dt="2024-12-30T18:44:34.649" v="884" actId="20577"/>
+      <pc:sldChg chg="modSp">
+        <pc:chgData name="Mohammed Fasha" userId="S::mohammed.fasha@uop.edu.jo::cc64f42d-a1a6-4f08-b97b-0c37f877119f" providerId="AD" clId="Web-{9DEFE369-4FE8-C0FA-AE89-88E89C96B65F}" dt="2025-04-07T19:01:20.830" v="42" actId="1076"/>
         <pc:sldMkLst>
           <pc:docMk/>
-          <pc:sldMk cId="916802035" sldId="651"/>
+          <pc:sldMk cId="0" sldId="281"/>
         </pc:sldMkLst>
+        <pc:picChg chg="mod">
+          <ac:chgData name="Mohammed Fasha" userId="S::mohammed.fasha@uop.edu.jo::cc64f42d-a1a6-4f08-b97b-0c37f877119f" providerId="AD" clId="Web-{9DEFE369-4FE8-C0FA-AE89-88E89C96B65F}" dt="2025-04-07T19:01:20.830" v="42" actId="1076"/>
+          <ac:picMkLst>
+            <pc:docMk/>
+            <pc:sldMk cId="0" sldId="281"/>
+            <ac:picMk id="4" creationId="{C1F36920-6CAD-70BE-C466-935BEA705640}"/>
+          </ac:picMkLst>
+        </pc:picChg>
       </pc:sldChg>
-      <pc:sldChg chg="del">
-        <pc:chgData name="Mohammed Fasha" userId="cc64f42d-a1a6-4f08-b97b-0c37f877119f" providerId="ADAL" clId="{BECD4A7F-C1AF-4585-8C31-FE7D4FE3ED16}" dt="2025-01-05T14:42:38.675" v="989" actId="2696"/>
+      <pc:sldChg chg="addSp delSp modSp">
+        <pc:chgData name="Mohammed Fasha" userId="S::mohammed.fasha@uop.edu.jo::cc64f42d-a1a6-4f08-b97b-0c37f877119f" providerId="AD" clId="Web-{9DEFE369-4FE8-C0FA-AE89-88E89C96B65F}" dt="2025-04-07T19:00:40.751" v="41" actId="14100"/>
         <pc:sldMkLst>
           <pc:docMk/>
-          <pc:sldMk cId="426516858" sldId="662"/>
+          <pc:sldMk cId="566407149" sldId="307"/>
         </pc:sldMkLst>
+        <pc:spChg chg="add del mod">
+          <ac:chgData name="Mohammed Fasha" userId="S::mohammed.fasha@uop.edu.jo::cc64f42d-a1a6-4f08-b97b-0c37f877119f" providerId="AD" clId="Web-{9DEFE369-4FE8-C0FA-AE89-88E89C96B65F}" dt="2025-04-07T18:57:07.869" v="14"/>
+          <ac:spMkLst>
+            <pc:docMk/>
+            <pc:sldMk cId="566407149" sldId="307"/>
+            <ac:spMk id="4" creationId="{0040CD8B-1B26-3594-C154-7524D9A6B713}"/>
+          </ac:spMkLst>
+        </pc:spChg>
+        <pc:spChg chg="add del mod">
+          <ac:chgData name="Mohammed Fasha" userId="S::mohammed.fasha@uop.edu.jo::cc64f42d-a1a6-4f08-b97b-0c37f877119f" providerId="AD" clId="Web-{9DEFE369-4FE8-C0FA-AE89-88E89C96B65F}" dt="2025-04-07T18:57:38.979" v="23"/>
+          <ac:spMkLst>
+            <pc:docMk/>
+            <pc:sldMk cId="566407149" sldId="307"/>
+            <ac:spMk id="8" creationId="{9DAC81FE-CF6A-619C-BE80-FA4ADE6B1065}"/>
+          </ac:spMkLst>
+        </pc:spChg>
+        <pc:picChg chg="add del mod ord">
+          <ac:chgData name="Mohammed Fasha" userId="S::mohammed.fasha@uop.edu.jo::cc64f42d-a1a6-4f08-b97b-0c37f877119f" providerId="AD" clId="Web-{9DEFE369-4FE8-C0FA-AE89-88E89C96B65F}" dt="2025-04-07T18:57:04.447" v="13"/>
+          <ac:picMkLst>
+            <pc:docMk/>
+            <pc:sldMk cId="566407149" sldId="307"/>
+            <ac:picMk id="5" creationId="{8EDC12A8-6612-7EAD-4B49-73F846796682}"/>
+          </ac:picMkLst>
+        </pc:picChg>
+        <pc:picChg chg="add del mod">
+          <ac:chgData name="Mohammed Fasha" userId="S::mohammed.fasha@uop.edu.jo::cc64f42d-a1a6-4f08-b97b-0c37f877119f" providerId="AD" clId="Web-{9DEFE369-4FE8-C0FA-AE89-88E89C96B65F}" dt="2025-04-07T18:58:07.652" v="33" actId="14100"/>
+          <ac:picMkLst>
+            <pc:docMk/>
+            <pc:sldMk cId="566407149" sldId="307"/>
+            <ac:picMk id="7" creationId="{52F9A5DE-4DA5-02A4-E05C-513BE84CC55D}"/>
+          </ac:picMkLst>
+        </pc:picChg>
+        <pc:picChg chg="mod">
+          <ac:chgData name="Mohammed Fasha" userId="S::mohammed.fasha@uop.edu.jo::cc64f42d-a1a6-4f08-b97b-0c37f877119f" providerId="AD" clId="Web-{9DEFE369-4FE8-C0FA-AE89-88E89C96B65F}" dt="2025-04-07T18:58:16.371" v="37" actId="1076"/>
+          <ac:picMkLst>
+            <pc:docMk/>
+            <pc:sldMk cId="566407149" sldId="307"/>
+            <ac:picMk id="9" creationId="{A97FD6D9-93B3-C33B-BA1A-25EAA798FBF7}"/>
+          </ac:picMkLst>
+        </pc:picChg>
+        <pc:picChg chg="add del mod ord">
+          <ac:chgData name="Mohammed Fasha" userId="S::mohammed.fasha@uop.edu.jo::cc64f42d-a1a6-4f08-b97b-0c37f877119f" providerId="AD" clId="Web-{9DEFE369-4FE8-C0FA-AE89-88E89C96B65F}" dt="2025-04-07T18:57:37.432" v="22"/>
+          <ac:picMkLst>
+            <pc:docMk/>
+            <pc:sldMk cId="566407149" sldId="307"/>
+            <ac:picMk id="10" creationId="{0AB83646-5D5F-02CD-6927-39E6A68A00E2}"/>
+          </ac:picMkLst>
+        </pc:picChg>
+        <pc:picChg chg="mod">
+          <ac:chgData name="Mohammed Fasha" userId="S::mohammed.fasha@uop.edu.jo::cc64f42d-a1a6-4f08-b97b-0c37f877119f" providerId="AD" clId="Web-{9DEFE369-4FE8-C0FA-AE89-88E89C96B65F}" dt="2025-04-07T19:00:40.751" v="41" actId="14100"/>
+          <ac:picMkLst>
+            <pc:docMk/>
+            <pc:sldMk cId="566407149" sldId="307"/>
+            <ac:picMk id="11" creationId="{0402BC08-439D-17A5-DBFC-F0D1CA4DBB8D}"/>
+          </ac:picMkLst>
+        </pc:picChg>
       </pc:sldChg>
-      <pc:sldChg chg="modSp add del mod">
-        <pc:chgData name="Mohammed Fasha" userId="cc64f42d-a1a6-4f08-b97b-0c37f877119f" providerId="ADAL" clId="{BECD4A7F-C1AF-4585-8C31-FE7D4FE3ED16}" dt="2025-01-05T16:34:59.233" v="1926" actId="20577"/>
+      <pc:sldChg chg="modSp">
+        <pc:chgData name="Mohammed Fasha" userId="S::mohammed.fasha@uop.edu.jo::cc64f42d-a1a6-4f08-b97b-0c37f877119f" providerId="AD" clId="Web-{9DEFE369-4FE8-C0FA-AE89-88E89C96B65F}" dt="2025-04-07T19:00:05.250" v="39" actId="1076"/>
         <pc:sldMkLst>
           <pc:docMk/>
-          <pc:sldMk cId="691538069" sldId="662"/>
+          <pc:sldMk cId="2501734364" sldId="308"/>
         </pc:sldMkLst>
+        <pc:picChg chg="mod">
+          <ac:chgData name="Mohammed Fasha" userId="S::mohammed.fasha@uop.edu.jo::cc64f42d-a1a6-4f08-b97b-0c37f877119f" providerId="AD" clId="Web-{9DEFE369-4FE8-C0FA-AE89-88E89C96B65F}" dt="2025-04-07T19:00:02.374" v="38" actId="14100"/>
+          <ac:picMkLst>
+            <pc:docMk/>
+            <pc:sldMk cId="2501734364" sldId="308"/>
+            <ac:picMk id="9" creationId="{F079DF9D-D91F-8F19-E096-CEB55AE60F5E}"/>
+          </ac:picMkLst>
+        </pc:picChg>
+        <pc:picChg chg="mod">
+          <ac:chgData name="Mohammed Fasha" userId="S::mohammed.fasha@uop.edu.jo::cc64f42d-a1a6-4f08-b97b-0c37f877119f" providerId="AD" clId="Web-{9DEFE369-4FE8-C0FA-AE89-88E89C96B65F}" dt="2025-04-07T19:00:05.250" v="39" actId="1076"/>
+          <ac:picMkLst>
+            <pc:docMk/>
+            <pc:sldMk cId="2501734364" sldId="308"/>
+            <ac:picMk id="11" creationId="{A62FBA81-FB50-9A3F-4551-5D02D03696AD}"/>
+          </ac:picMkLst>
+        </pc:picChg>
       </pc:sldChg>
-      <pc:sldChg chg="del">
-        <pc:chgData name="Mohammed Fasha" userId="cc64f42d-a1a6-4f08-b97b-0c37f877119f" providerId="ADAL" clId="{BECD4A7F-C1AF-4585-8C31-FE7D4FE3ED16}" dt="2025-01-05T14:42:38.675" v="989" actId="2696"/>
-        <pc:sldMkLst>
-          <pc:docMk/>
-          <pc:sldMk cId="895445062" sldId="663"/>
-        </pc:sldMkLst>
-      </pc:sldChg>
-      <pc:sldChg chg="add del">
-        <pc:chgData name="Mohammed Fasha" userId="cc64f42d-a1a6-4f08-b97b-0c37f877119f" providerId="ADAL" clId="{BECD4A7F-C1AF-4585-8C31-FE7D4FE3ED16}" dt="2025-01-05T14:43:16.100" v="993" actId="2696"/>
-        <pc:sldMkLst>
-          <pc:docMk/>
-          <pc:sldMk cId="3980180774" sldId="663"/>
-        </pc:sldMkLst>
-      </pc:sldChg>
-      <pc:sldChg chg="add del">
-        <pc:chgData name="Mohammed Fasha" userId="cc64f42d-a1a6-4f08-b97b-0c37f877119f" providerId="ADAL" clId="{BECD4A7F-C1AF-4585-8C31-FE7D4FE3ED16}" dt="2025-01-05T14:43:16.100" v="993" actId="2696"/>
-        <pc:sldMkLst>
-          <pc:docMk/>
-          <pc:sldMk cId="1728680596" sldId="664"/>
-        </pc:sldMkLst>
-      </pc:sldChg>
-      <pc:sldChg chg="del">
-        <pc:chgData name="Mohammed Fasha" userId="cc64f42d-a1a6-4f08-b97b-0c37f877119f" providerId="ADAL" clId="{BECD4A7F-C1AF-4585-8C31-FE7D4FE3ED16}" dt="2025-01-05T14:42:38.675" v="989" actId="2696"/>
-        <pc:sldMkLst>
-          <pc:docMk/>
-          <pc:sldMk cId="3900588277" sldId="664"/>
-        </pc:sldMkLst>
-      </pc:sldChg>
-      <pc:sldChg chg="del">
-        <pc:chgData name="Mohammed Fasha" userId="cc64f42d-a1a6-4f08-b97b-0c37f877119f" providerId="ADAL" clId="{BECD4A7F-C1AF-4585-8C31-FE7D4FE3ED16}" dt="2025-01-05T14:42:38.675" v="989" actId="2696"/>
-        <pc:sldMkLst>
-          <pc:docMk/>
-          <pc:sldMk cId="123002105" sldId="665"/>
-        </pc:sldMkLst>
-      </pc:sldChg>
-      <pc:sldChg chg="modSp add del mod">
-        <pc:chgData name="Mohammed Fasha" userId="cc64f42d-a1a6-4f08-b97b-0c37f877119f" providerId="ADAL" clId="{BECD4A7F-C1AF-4585-8C31-FE7D4FE3ED16}" dt="2025-01-05T15:05:12.729" v="1226" actId="21"/>
-        <pc:sldMkLst>
-          <pc:docMk/>
-          <pc:sldMk cId="148099094" sldId="665"/>
-        </pc:sldMkLst>
-      </pc:sldChg>
-      <pc:sldChg chg="del">
-        <pc:chgData name="Mohammed Fasha" userId="cc64f42d-a1a6-4f08-b97b-0c37f877119f" providerId="ADAL" clId="{BECD4A7F-C1AF-4585-8C31-FE7D4FE3ED16}" dt="2025-01-05T14:42:38.675" v="989" actId="2696"/>
-        <pc:sldMkLst>
-          <pc:docMk/>
-          <pc:sldMk cId="659863378" sldId="676"/>
-        </pc:sldMkLst>
-      </pc:sldChg>
-      <pc:sldChg chg="modSp add del mod">
-        <pc:chgData name="Mohammed Fasha" userId="cc64f42d-a1a6-4f08-b97b-0c37f877119f" providerId="ADAL" clId="{BECD4A7F-C1AF-4585-8C31-FE7D4FE3ED16}" dt="2025-01-05T14:55:27.595" v="1130" actId="255"/>
-        <pc:sldMkLst>
-          <pc:docMk/>
-          <pc:sldMk cId="1577854815" sldId="676"/>
-        </pc:sldMkLst>
-      </pc:sldChg>
-      <pc:sldChg chg="modSp add del mod">
-        <pc:chgData name="Mohammed Fasha" userId="cc64f42d-a1a6-4f08-b97b-0c37f877119f" providerId="ADAL" clId="{BECD4A7F-C1AF-4585-8C31-FE7D4FE3ED16}" dt="2025-01-05T14:55:43.754" v="1132" actId="1076"/>
-        <pc:sldMkLst>
-          <pc:docMk/>
-          <pc:sldMk cId="139882925" sldId="677"/>
-        </pc:sldMkLst>
-      </pc:sldChg>
-      <pc:sldChg chg="del">
-        <pc:chgData name="Mohammed Fasha" userId="cc64f42d-a1a6-4f08-b97b-0c37f877119f" providerId="ADAL" clId="{BECD4A7F-C1AF-4585-8C31-FE7D4FE3ED16}" dt="2025-01-05T14:42:38.675" v="989" actId="2696"/>
-        <pc:sldMkLst>
-          <pc:docMk/>
-          <pc:sldMk cId="2736863534" sldId="677"/>
-        </pc:sldMkLst>
-      </pc:sldChg>
-      <pc:sldChg chg="add del">
-        <pc:chgData name="Mohammed Fasha" userId="cc64f42d-a1a6-4f08-b97b-0c37f877119f" providerId="ADAL" clId="{BECD4A7F-C1AF-4585-8C31-FE7D4FE3ED16}" dt="2025-01-05T14:43:16.100" v="993" actId="2696"/>
-        <pc:sldMkLst>
-          <pc:docMk/>
-          <pc:sldMk cId="4146654093" sldId="678"/>
-        </pc:sldMkLst>
-      </pc:sldChg>
-      <pc:sldChg chg="del">
-        <pc:chgData name="Mohammed Fasha" userId="cc64f42d-a1a6-4f08-b97b-0c37f877119f" providerId="ADAL" clId="{BECD4A7F-C1AF-4585-8C31-FE7D4FE3ED16}" dt="2025-01-05T14:42:38.675" v="989" actId="2696"/>
-        <pc:sldMkLst>
-          <pc:docMk/>
-          <pc:sldMk cId="4228312762" sldId="678"/>
-        </pc:sldMkLst>
-      </pc:sldChg>
-      <pc:sldChg chg="del">
-        <pc:chgData name="Mohammed Fasha" userId="cc64f42d-a1a6-4f08-b97b-0c37f877119f" providerId="ADAL" clId="{BECD4A7F-C1AF-4585-8C31-FE7D4FE3ED16}" dt="2025-01-05T14:42:38.675" v="989" actId="2696"/>
-        <pc:sldMkLst>
-          <pc:docMk/>
-          <pc:sldMk cId="581717462" sldId="679"/>
-        </pc:sldMkLst>
-      </pc:sldChg>
-      <pc:sldChg chg="addSp delSp modSp add del mod chgLayout">
-        <pc:chgData name="Mohammed Fasha" userId="cc64f42d-a1a6-4f08-b97b-0c37f877119f" providerId="ADAL" clId="{BECD4A7F-C1AF-4585-8C31-FE7D4FE3ED16}" dt="2025-01-05T16:36:16.605" v="1945" actId="1076"/>
-        <pc:sldMkLst>
-          <pc:docMk/>
-          <pc:sldMk cId="3454522070" sldId="679"/>
-        </pc:sldMkLst>
-      </pc:sldChg>
-      <pc:sldChg chg="add del">
-        <pc:chgData name="Mohammed Fasha" userId="cc64f42d-a1a6-4f08-b97b-0c37f877119f" providerId="ADAL" clId="{BECD4A7F-C1AF-4585-8C31-FE7D4FE3ED16}" dt="2025-01-05T14:43:16.100" v="993" actId="2696"/>
-        <pc:sldMkLst>
-          <pc:docMk/>
-          <pc:sldMk cId="2856814121" sldId="681"/>
-        </pc:sldMkLst>
-      </pc:sldChg>
-      <pc:sldChg chg="del">
-        <pc:chgData name="Mohammed Fasha" userId="cc64f42d-a1a6-4f08-b97b-0c37f877119f" providerId="ADAL" clId="{BECD4A7F-C1AF-4585-8C31-FE7D4FE3ED16}" dt="2025-01-05T14:42:38.675" v="989" actId="2696"/>
-        <pc:sldMkLst>
-          <pc:docMk/>
-          <pc:sldMk cId="3083966018" sldId="681"/>
-        </pc:sldMkLst>
-      </pc:sldChg>
-      <pc:sldChg chg="modSp mod">
-        <pc:chgData name="Mohammed Fasha" userId="cc64f42d-a1a6-4f08-b97b-0c37f877119f" providerId="ADAL" clId="{BECD4A7F-C1AF-4585-8C31-FE7D4FE3ED16}" dt="2025-01-05T14:42:50.596" v="990" actId="14100"/>
-        <pc:sldMkLst>
-          <pc:docMk/>
-          <pc:sldMk cId="1697141369" sldId="695"/>
-        </pc:sldMkLst>
-      </pc:sldChg>
-      <pc:sldChg chg="addSp delSp modSp add del mod">
-        <pc:chgData name="Mohammed Fasha" userId="cc64f42d-a1a6-4f08-b97b-0c37f877119f" providerId="ADAL" clId="{BECD4A7F-C1AF-4585-8C31-FE7D4FE3ED16}" dt="2025-01-05T14:54:31.375" v="1125" actId="14100"/>
-        <pc:sldMkLst>
-          <pc:docMk/>
-          <pc:sldMk cId="265576630" sldId="698"/>
-        </pc:sldMkLst>
-      </pc:sldChg>
-      <pc:sldChg chg="del">
-        <pc:chgData name="Mohammed Fasha" userId="cc64f42d-a1a6-4f08-b97b-0c37f877119f" providerId="ADAL" clId="{BECD4A7F-C1AF-4585-8C31-FE7D4FE3ED16}" dt="2025-01-05T14:42:38.675" v="989" actId="2696"/>
-        <pc:sldMkLst>
-          <pc:docMk/>
-          <pc:sldMk cId="991725834" sldId="698"/>
-        </pc:sldMkLst>
-      </pc:sldChg>
-      <pc:sldChg chg="del">
-        <pc:chgData name="Mohammed Fasha" userId="cc64f42d-a1a6-4f08-b97b-0c37f877119f" providerId="ADAL" clId="{BECD4A7F-C1AF-4585-8C31-FE7D4FE3ED16}" dt="2025-01-05T14:42:38.675" v="989" actId="2696"/>
-        <pc:sldMkLst>
-          <pc:docMk/>
-          <pc:sldMk cId="3109561867" sldId="700"/>
-        </pc:sldMkLst>
-      </pc:sldChg>
-      <pc:sldChg chg="addSp delSp modSp add del mod">
-        <pc:chgData name="Mohammed Fasha" userId="cc64f42d-a1a6-4f08-b97b-0c37f877119f" providerId="ADAL" clId="{BECD4A7F-C1AF-4585-8C31-FE7D4FE3ED16}" dt="2025-01-05T16:00:05.564" v="1529" actId="20577"/>
-        <pc:sldMkLst>
-          <pc:docMk/>
-          <pc:sldMk cId="4247717824" sldId="700"/>
-        </pc:sldMkLst>
-      </pc:sldChg>
-      <pc:sldChg chg="addSp delSp modSp add mod">
-        <pc:chgData name="Mohammed Fasha" userId="cc64f42d-a1a6-4f08-b97b-0c37f877119f" providerId="ADAL" clId="{BECD4A7F-C1AF-4585-8C31-FE7D4FE3ED16}" dt="2025-01-05T14:53:29.185" v="1101" actId="21"/>
-        <pc:sldMkLst>
-          <pc:docMk/>
-          <pc:sldMk cId="67871309" sldId="709"/>
-        </pc:sldMkLst>
-      </pc:sldChg>
-      <pc:sldChg chg="modSp add mod">
-        <pc:chgData name="Mohammed Fasha" userId="cc64f42d-a1a6-4f08-b97b-0c37f877119f" providerId="ADAL" clId="{BECD4A7F-C1AF-4585-8C31-FE7D4FE3ED16}" dt="2025-01-05T15:31:09.113" v="1385" actId="6549"/>
-        <pc:sldMkLst>
-          <pc:docMk/>
-          <pc:sldMk cId="4114896152" sldId="710"/>
-        </pc:sldMkLst>
-      </pc:sldChg>
-      <pc:sldChg chg="addSp modSp add mod">
-        <pc:chgData name="Mohammed Fasha" userId="cc64f42d-a1a6-4f08-b97b-0c37f877119f" providerId="ADAL" clId="{BECD4A7F-C1AF-4585-8C31-FE7D4FE3ED16}" dt="2025-01-05T15:27:36.027" v="1348" actId="20577"/>
-        <pc:sldMkLst>
-          <pc:docMk/>
-          <pc:sldMk cId="3794385322" sldId="711"/>
-        </pc:sldMkLst>
-      </pc:sldChg>
-      <pc:sldChg chg="add del">
-        <pc:chgData name="Mohammed Fasha" userId="cc64f42d-a1a6-4f08-b97b-0c37f877119f" providerId="ADAL" clId="{BECD4A7F-C1AF-4585-8C31-FE7D4FE3ED16}" dt="2025-01-05T14:57:43.613" v="1146" actId="2696"/>
-        <pc:sldMkLst>
-          <pc:docMk/>
-          <pc:sldMk cId="501127302" sldId="712"/>
-        </pc:sldMkLst>
-      </pc:sldChg>
-      <pc:sldChg chg="modSp add mod">
-        <pc:chgData name="Mohammed Fasha" userId="cc64f42d-a1a6-4f08-b97b-0c37f877119f" providerId="ADAL" clId="{BECD4A7F-C1AF-4585-8C31-FE7D4FE3ED16}" dt="2025-01-05T15:32:23.870" v="1388"/>
-        <pc:sldMkLst>
-          <pc:docMk/>
-          <pc:sldMk cId="3701206727" sldId="712"/>
-        </pc:sldMkLst>
-      </pc:sldChg>
-      <pc:sldChg chg="addSp modSp add mod">
-        <pc:chgData name="Mohammed Fasha" userId="cc64f42d-a1a6-4f08-b97b-0c37f877119f" providerId="ADAL" clId="{BECD4A7F-C1AF-4585-8C31-FE7D4FE3ED16}" dt="2025-01-05T16:06:36.028" v="1538" actId="1076"/>
-        <pc:sldMkLst>
-          <pc:docMk/>
-          <pc:sldMk cId="1499972066" sldId="713"/>
-        </pc:sldMkLst>
-      </pc:sldChg>
-      <pc:sldChg chg="addSp delSp modSp add mod">
-        <pc:chgData name="Mohammed Fasha" userId="cc64f42d-a1a6-4f08-b97b-0c37f877119f" providerId="ADAL" clId="{BECD4A7F-C1AF-4585-8C31-FE7D4FE3ED16}" dt="2025-01-05T16:19:08.436" v="1705" actId="1036"/>
-        <pc:sldMkLst>
-          <pc:docMk/>
-          <pc:sldMk cId="1270641495" sldId="714"/>
-        </pc:sldMkLst>
-      </pc:sldChg>
-      <pc:sldChg chg="addSp modSp new mod">
-        <pc:chgData name="Mohammed Fasha" userId="cc64f42d-a1a6-4f08-b97b-0c37f877119f" providerId="ADAL" clId="{BECD4A7F-C1AF-4585-8C31-FE7D4FE3ED16}" dt="2025-01-05T16:23:44.632" v="1736" actId="12"/>
-        <pc:sldMkLst>
-          <pc:docMk/>
-          <pc:sldMk cId="1096386322" sldId="715"/>
-        </pc:sldMkLst>
-      </pc:sldChg>
-      <pc:sldChg chg="modSp new mod">
-        <pc:chgData name="Mohammed Fasha" userId="cc64f42d-a1a6-4f08-b97b-0c37f877119f" providerId="ADAL" clId="{BECD4A7F-C1AF-4585-8C31-FE7D4FE3ED16}" dt="2025-01-05T16:34:02.360" v="1902" actId="27636"/>
-        <pc:sldMkLst>
-          <pc:docMk/>
-          <pc:sldMk cId="1784058309" sldId="716"/>
-        </pc:sldMkLst>
-      </pc:sldChg>
-      <pc:sldChg chg="modSp add mod ord">
-        <pc:chgData name="Mohammed Fasha" userId="cc64f42d-a1a6-4f08-b97b-0c37f877119f" providerId="ADAL" clId="{BECD4A7F-C1AF-4585-8C31-FE7D4FE3ED16}" dt="2025-01-05T16:27:20.520" v="1803"/>
-        <pc:sldMkLst>
-          <pc:docMk/>
-          <pc:sldMk cId="3139017106" sldId="717"/>
-        </pc:sldMkLst>
-      </pc:sldChg>
-      <pc:sldChg chg="addSp delSp modSp new mod">
-        <pc:chgData name="Mohammed Fasha" userId="cc64f42d-a1a6-4f08-b97b-0c37f877119f" providerId="ADAL" clId="{BECD4A7F-C1AF-4585-8C31-FE7D4FE3ED16}" dt="2025-01-05T16:32:45.446" v="1897" actId="20577"/>
-        <pc:sldMkLst>
-          <pc:docMk/>
-          <pc:sldMk cId="3043812923" sldId="718"/>
-        </pc:sldMkLst>
-      </pc:sldChg>
-    </pc:docChg>
-  </pc:docChgLst>
-  <pc:docChgLst>
-    <pc:chgData name="Mohammed Fasha" userId="cc64f42d-a1a6-4f08-b97b-0c37f877119f" providerId="ADAL" clId="{2E5FBF59-3168-4932-9518-582502FE1AD5}"/>
-    <pc:docChg chg="undo custSel delSld modSld">
-      <pc:chgData name="Mohammed Fasha" userId="cc64f42d-a1a6-4f08-b97b-0c37f877119f" providerId="ADAL" clId="{2E5FBF59-3168-4932-9518-582502FE1AD5}" dt="2024-12-24T08:08:19.987" v="550" actId="20577"/>
-      <pc:docMkLst>
-        <pc:docMk/>
-      </pc:docMkLst>
-      <pc:sldChg chg="delSp">
-        <pc:chgData name="Mohammed Fasha" userId="cc64f42d-a1a6-4f08-b97b-0c37f877119f" providerId="ADAL" clId="{2E5FBF59-3168-4932-9518-582502FE1AD5}" dt="2024-11-19T07:40:47.121" v="208" actId="478"/>
-        <pc:sldMkLst>
-          <pc:docMk/>
-          <pc:sldMk cId="391491219" sldId="428"/>
-        </pc:sldMkLst>
-      </pc:sldChg>
-      <pc:sldChg chg="modSp">
-        <pc:chgData name="Mohammed Fasha" userId="cc64f42d-a1a6-4f08-b97b-0c37f877119f" providerId="ADAL" clId="{2E5FBF59-3168-4932-9518-582502FE1AD5}" dt="2024-12-03T07:43:58.007" v="456" actId="1076"/>
-        <pc:sldMkLst>
-          <pc:docMk/>
-          <pc:sldMk cId="3339445507" sldId="430"/>
-        </pc:sldMkLst>
-      </pc:sldChg>
-      <pc:sldChg chg="modSp">
-        <pc:chgData name="Mohammed Fasha" userId="cc64f42d-a1a6-4f08-b97b-0c37f877119f" providerId="ADAL" clId="{2E5FBF59-3168-4932-9518-582502FE1AD5}" dt="2024-12-03T07:45:08.136" v="474" actId="20577"/>
-        <pc:sldMkLst>
-          <pc:docMk/>
-          <pc:sldMk cId="3389046835" sldId="431"/>
-        </pc:sldMkLst>
-      </pc:sldChg>
-      <pc:sldChg chg="modSp">
-        <pc:chgData name="Mohammed Fasha" userId="cc64f42d-a1a6-4f08-b97b-0c37f877119f" providerId="ADAL" clId="{2E5FBF59-3168-4932-9518-582502FE1AD5}" dt="2024-11-10T06:33:09.727" v="37" actId="207"/>
-        <pc:sldMkLst>
-          <pc:docMk/>
-          <pc:sldMk cId="2726994946" sldId="479"/>
-        </pc:sldMkLst>
-      </pc:sldChg>
-      <pc:sldChg chg="modSp">
-        <pc:chgData name="Mohammed Fasha" userId="cc64f42d-a1a6-4f08-b97b-0c37f877119f" providerId="ADAL" clId="{2E5FBF59-3168-4932-9518-582502FE1AD5}" dt="2024-11-19T07:44:28.766" v="211" actId="20577"/>
-        <pc:sldMkLst>
-          <pc:docMk/>
-          <pc:sldMk cId="2297456757" sldId="483"/>
-        </pc:sldMkLst>
-      </pc:sldChg>
-      <pc:sldChg chg="modSp">
-        <pc:chgData name="Mohammed Fasha" userId="cc64f42d-a1a6-4f08-b97b-0c37f877119f" providerId="ADAL" clId="{2E5FBF59-3168-4932-9518-582502FE1AD5}" dt="2024-11-10T06:45:09.392" v="40" actId="20577"/>
-        <pc:sldMkLst>
-          <pc:docMk/>
-          <pc:sldMk cId="3474268344" sldId="596"/>
-        </pc:sldMkLst>
-      </pc:sldChg>
-      <pc:sldChg chg="modSp">
-        <pc:chgData name="Mohammed Fasha" userId="cc64f42d-a1a6-4f08-b97b-0c37f877119f" providerId="ADAL" clId="{2E5FBF59-3168-4932-9518-582502FE1AD5}" dt="2024-12-03T07:47:21.561" v="476" actId="6549"/>
-        <pc:sldMkLst>
-          <pc:docMk/>
-          <pc:sldMk cId="399592497" sldId="613"/>
-        </pc:sldMkLst>
-      </pc:sldChg>
-      <pc:sldChg chg="modSp">
-        <pc:chgData name="Mohammed Fasha" userId="cc64f42d-a1a6-4f08-b97b-0c37f877119f" providerId="ADAL" clId="{2E5FBF59-3168-4932-9518-582502FE1AD5}" dt="2024-12-03T07:49:02.980" v="478" actId="207"/>
-        <pc:sldMkLst>
-          <pc:docMk/>
-          <pc:sldMk cId="3329135496" sldId="617"/>
-        </pc:sldMkLst>
-      </pc:sldChg>
-      <pc:sldChg chg="modSp">
-        <pc:chgData name="Mohammed Fasha" userId="cc64f42d-a1a6-4f08-b97b-0c37f877119f" providerId="ADAL" clId="{2E5FBF59-3168-4932-9518-582502FE1AD5}" dt="2024-12-24T08:05:16.608" v="482" actId="403"/>
-        <pc:sldMkLst>
-          <pc:docMk/>
-          <pc:sldMk cId="2990045589" sldId="659"/>
-        </pc:sldMkLst>
-      </pc:sldChg>
-      <pc:sldChg chg="modSp">
-        <pc:chgData name="Mohammed Fasha" userId="cc64f42d-a1a6-4f08-b97b-0c37f877119f" providerId="ADAL" clId="{2E5FBF59-3168-4932-9518-582502FE1AD5}" dt="2024-12-24T08:08:19.987" v="550" actId="20577"/>
-        <pc:sldMkLst>
-          <pc:docMk/>
-          <pc:sldMk cId="2680231355" sldId="669"/>
-        </pc:sldMkLst>
-      </pc:sldChg>
-      <pc:sldChg chg="addSp modSp">
-        <pc:chgData name="Mohammed Fasha" userId="cc64f42d-a1a6-4f08-b97b-0c37f877119f" providerId="ADAL" clId="{2E5FBF59-3168-4932-9518-582502FE1AD5}" dt="2024-12-24T08:05:52.910" v="488" actId="1076"/>
-        <pc:sldMkLst>
-          <pc:docMk/>
-          <pc:sldMk cId="916102856" sldId="685"/>
-        </pc:sldMkLst>
-      </pc:sldChg>
-      <pc:sldChg chg="modSp">
-        <pc:chgData name="Mohammed Fasha" userId="cc64f42d-a1a6-4f08-b97b-0c37f877119f" providerId="ADAL" clId="{2E5FBF59-3168-4932-9518-582502FE1AD5}" dt="2024-11-19T07:03:29.557" v="206" actId="207"/>
-        <pc:sldMkLst>
-          <pc:docMk/>
-          <pc:sldMk cId="32004852" sldId="708"/>
-        </pc:sldMkLst>
-      </pc:sldChg>
-    </pc:docChg>
-  </pc:docChgLst>
-  <pc:docChgLst>
-    <pc:chgData name="Mohammed Fasha" userId="cc64f42d-a1a6-4f08-b97b-0c37f877119f" providerId="ADAL" clId="{6804A8E6-8D7F-46E3-B091-66A8F6B926BF}"/>
-    <pc:docChg chg="custSel modMainMaster">
-      <pc:chgData name="Mohammed Fasha" userId="cc64f42d-a1a6-4f08-b97b-0c37f877119f" providerId="ADAL" clId="{6804A8E6-8D7F-46E3-B091-66A8F6B926BF}" dt="2024-11-09T05:15:35.019" v="2" actId="1076"/>
-      <pc:docMkLst>
-        <pc:docMk/>
-      </pc:docMkLst>
-      <pc:sldMasterChg chg="delSp mod modSldLayout">
-        <pc:chgData name="Mohammed Fasha" userId="cc64f42d-a1a6-4f08-b97b-0c37f877119f" providerId="ADAL" clId="{6804A8E6-8D7F-46E3-B091-66A8F6B926BF}" dt="2024-11-09T05:15:35.019" v="2" actId="1076"/>
-        <pc:sldMasterMkLst>
-          <pc:docMk/>
-          <pc:sldMasterMk cId="742811419" sldId="2147483648"/>
-        </pc:sldMasterMkLst>
-        <pc:sldLayoutChg chg="addSp modSp mod">
-          <pc:chgData name="Mohammed Fasha" userId="cc64f42d-a1a6-4f08-b97b-0c37f877119f" providerId="ADAL" clId="{6804A8E6-8D7F-46E3-B091-66A8F6B926BF}" dt="2024-11-09T05:15:35.019" v="2" actId="1076"/>
-          <pc:sldLayoutMkLst>
-            <pc:docMk/>
-            <pc:sldMasterMk cId="742811419" sldId="2147483648"/>
-            <pc:sldLayoutMk cId="4063788262" sldId="2147483649"/>
-          </pc:sldLayoutMkLst>
-        </pc:sldLayoutChg>
-      </pc:sldMasterChg>
     </pc:docChg>
   </pc:docChgLst>
 </pc:chgInfo>
@@ -6574,7 +6775,7 @@
           <a:p>
             <a:fld id="{13BA03A4-B9F1-404C-8A74-B1AFD6480953}" type="datetimeFigureOut">
               <a:rPr lang="en-US" smtClean="0"/>
-              <a:t>4/6/2025</a:t>
+              <a:t>4/7/2025</a:t>
             </a:fld>
             <a:endParaRPr lang="en-US"/>
           </a:p>
@@ -6988,7 +7189,7 @@
           <a:p>
             <a:fld id="{0DB78E95-DE77-44D3-BDB9-E242948FB112}" type="datetimeFigureOut">
               <a:rPr lang="en-US" smtClean="0"/>
-              <a:t>4/6/2025</a:t>
+              <a:t>4/7/2025</a:t>
             </a:fld>
             <a:endParaRPr lang="en-US"/>
           </a:p>
@@ -7216,7 +7417,7 @@
           <a:p>
             <a:fld id="{0DB78E95-DE77-44D3-BDB9-E242948FB112}" type="datetimeFigureOut">
               <a:rPr lang="en-US" smtClean="0"/>
-              <a:t>4/6/2025</a:t>
+              <a:t>4/7/2025</a:t>
             </a:fld>
             <a:endParaRPr lang="en-US"/>
           </a:p>
@@ -7424,7 +7625,7 @@
           <a:p>
             <a:fld id="{0DB78E95-DE77-44D3-BDB9-E242948FB112}" type="datetimeFigureOut">
               <a:rPr lang="en-US" smtClean="0"/>
-              <a:t>4/6/2025</a:t>
+              <a:t>4/7/2025</a:t>
             </a:fld>
             <a:endParaRPr lang="en-US"/>
           </a:p>
@@ -8151,7 +8352,7 @@
           <a:p>
             <a:fld id="{0DB78E95-DE77-44D3-BDB9-E242948FB112}" type="datetimeFigureOut">
               <a:rPr lang="en-US" smtClean="0"/>
-              <a:t>4/6/2025</a:t>
+              <a:t>4/7/2025</a:t>
             </a:fld>
             <a:endParaRPr lang="en-US"/>
           </a:p>
@@ -8530,7 +8731,7 @@
           <a:p>
             <a:fld id="{0DB78E95-DE77-44D3-BDB9-E242948FB112}" type="datetimeFigureOut">
               <a:rPr lang="en-US" smtClean="0"/>
-              <a:t>4/6/2025</a:t>
+              <a:t>4/7/2025</a:t>
             </a:fld>
             <a:endParaRPr lang="en-US"/>
           </a:p>
@@ -8942,7 +9143,7 @@
           <a:p>
             <a:fld id="{0DB78E95-DE77-44D3-BDB9-E242948FB112}" type="datetimeFigureOut">
               <a:rPr lang="en-US" smtClean="0"/>
-              <a:t>4/6/2025</a:t>
+              <a:t>4/7/2025</a:t>
             </a:fld>
             <a:endParaRPr lang="en-US"/>
           </a:p>
@@ -9083,7 +9284,7 @@
           <a:p>
             <a:fld id="{0DB78E95-DE77-44D3-BDB9-E242948FB112}" type="datetimeFigureOut">
               <a:rPr lang="en-US" smtClean="0"/>
-              <a:t>4/6/2025</a:t>
+              <a:t>4/7/2025</a:t>
             </a:fld>
             <a:endParaRPr lang="en-US"/>
           </a:p>
@@ -9196,7 +9397,7 @@
           <a:p>
             <a:fld id="{0DB78E95-DE77-44D3-BDB9-E242948FB112}" type="datetimeFigureOut">
               <a:rPr lang="en-US" smtClean="0"/>
-              <a:t>4/6/2025</a:t>
+              <a:t>4/7/2025</a:t>
             </a:fld>
             <a:endParaRPr lang="en-US"/>
           </a:p>
@@ -9507,7 +9708,7 @@
           <a:p>
             <a:fld id="{0DB78E95-DE77-44D3-BDB9-E242948FB112}" type="datetimeFigureOut">
               <a:rPr lang="en-US" smtClean="0"/>
-              <a:t>4/6/2025</a:t>
+              <a:t>4/7/2025</a:t>
             </a:fld>
             <a:endParaRPr lang="en-US"/>
           </a:p>
@@ -9795,7 +9996,7 @@
           <a:p>
             <a:fld id="{0DB78E95-DE77-44D3-BDB9-E242948FB112}" type="datetimeFigureOut">
               <a:rPr lang="en-US" smtClean="0"/>
-              <a:t>4/6/2025</a:t>
+              <a:t>4/7/2025</a:t>
             </a:fld>
             <a:endParaRPr lang="en-US"/>
           </a:p>
@@ -10036,7 +10237,7 @@
           <a:p>
             <a:fld id="{0DB78E95-DE77-44D3-BDB9-E242948FB112}" type="datetimeFigureOut">
               <a:rPr lang="en-US" smtClean="0"/>
-              <a:t>4/6/2025</a:t>
+              <a:t>4/7/2025</a:t>
             </a:fld>
             <a:endParaRPr lang="en-US"/>
           </a:p>
@@ -11677,7 +11878,7 @@
         </p:blipFill>
         <p:spPr>
           <a:xfrm>
-            <a:off x="10431000" y="6231240"/>
+            <a:off x="10525407" y="6231240"/>
             <a:ext cx="1114200" cy="190080"/>
           </a:xfrm>
           <a:prstGeom prst="rect">
@@ -12790,7 +12991,7 @@
         </p:blipFill>
         <p:spPr>
           <a:xfrm>
-            <a:off x="10431000" y="6231240"/>
+            <a:off x="10525407" y="6231240"/>
             <a:ext cx="1114200" cy="190080"/>
           </a:xfrm>
           <a:prstGeom prst="rect">
@@ -13624,7 +13825,7 @@
         </p:blipFill>
         <p:spPr>
           <a:xfrm>
-            <a:off x="10431000" y="6231240"/>
+            <a:off x="10525407" y="6231240"/>
             <a:ext cx="1114200" cy="190080"/>
           </a:xfrm>
           <a:prstGeom prst="rect">
@@ -15474,7 +15675,7 @@
         </p:blipFill>
         <p:spPr>
           <a:xfrm>
-            <a:off x="10431000" y="6231240"/>
+            <a:off x="10525407" y="6231240"/>
             <a:ext cx="1114200" cy="190080"/>
           </a:xfrm>
           <a:prstGeom prst="rect">
@@ -18431,7 +18632,7 @@
         </p:blipFill>
         <p:spPr>
           <a:xfrm>
-            <a:off x="10431000" y="6231240"/>
+            <a:off x="10525407" y="6231240"/>
             <a:ext cx="1114200" cy="190080"/>
           </a:xfrm>
           <a:prstGeom prst="rect">
@@ -24799,7 +25000,7 @@
         </p:blipFill>
         <p:spPr>
           <a:xfrm>
-            <a:off x="10431000" y="6231240"/>
+            <a:off x="10525408" y="6231240"/>
             <a:ext cx="1114200" cy="190080"/>
           </a:xfrm>
           <a:prstGeom prst="rect">
@@ -25792,7 +25993,7 @@
         </p:blipFill>
         <p:spPr>
           <a:xfrm>
-            <a:off x="10431000" y="6231240"/>
+            <a:off x="10518664" y="6231240"/>
             <a:ext cx="1114200" cy="190080"/>
           </a:xfrm>
           <a:prstGeom prst="rect">
@@ -26225,8 +26426,8 @@
         </p:blipFill>
         <p:spPr>
           <a:xfrm>
-            <a:off x="838199" y="1808318"/>
-            <a:ext cx="5147847" cy="2343735"/>
+            <a:off x="838199" y="1646478"/>
+            <a:ext cx="5511988" cy="2505575"/>
           </a:xfrm>
         </p:spPr>
       </p:pic>
@@ -26252,7 +26453,7 @@
         </p:blipFill>
         <p:spPr>
           <a:xfrm>
-            <a:off x="838200" y="4363669"/>
+            <a:off x="838200" y="4444589"/>
             <a:ext cx="8376564" cy="2086814"/>
           </a:xfrm>
           <a:prstGeom prst="rect">
@@ -27985,7 +28186,7 @@
         </p:blipFill>
         <p:spPr>
           <a:xfrm>
-            <a:off x="838200" y="1774332"/>
+            <a:off x="898890" y="1774332"/>
             <a:ext cx="5492669" cy="2281881"/>
           </a:xfrm>
         </p:spPr>
@@ -28012,8 +28213,8 @@
         </p:blipFill>
         <p:spPr>
           <a:xfrm>
-            <a:off x="8382149" y="4521695"/>
-            <a:ext cx="2672602" cy="1934712"/>
+            <a:off x="7357158" y="3651801"/>
+            <a:ext cx="3717823" cy="2730428"/>
           </a:xfrm>
           <a:prstGeom prst="rect">
             <a:avLst/>
@@ -28042,8 +28243,8 @@
         </p:blipFill>
         <p:spPr>
           <a:xfrm>
-            <a:off x="1022012" y="4056213"/>
-            <a:ext cx="3874740" cy="2498573"/>
+            <a:off x="968065" y="4224797"/>
+            <a:ext cx="3948916" cy="2545776"/>
           </a:xfrm>
           <a:prstGeom prst="rect">
             <a:avLst/>

</xml_diff>